<commit_message>
added small note on protocols
</commit_message>
<xml_diff>
--- a/Intro to Computers/Lesson 02 - Networking Basics/Lesson 2 - Network Basics.pptx
+++ b/Intro to Computers/Lesson 02 - Networking Basics/Lesson 2 - Network Basics.pptx
@@ -5,27 +5,28 @@
     <p:sldMasterId id="2147483664" r:id="rId1"/>
   </p:sldMasterIdLst>
   <p:notesMasterIdLst>
-    <p:notesMasterId r:id="rId20"/>
+    <p:notesMasterId r:id="rId21"/>
   </p:notesMasterIdLst>
   <p:sldIdLst>
     <p:sldId id="256" r:id="rId2"/>
     <p:sldId id="294" r:id="rId3"/>
     <p:sldId id="295" r:id="rId4"/>
     <p:sldId id="296" r:id="rId5"/>
-    <p:sldId id="297" r:id="rId6"/>
-    <p:sldId id="298" r:id="rId7"/>
-    <p:sldId id="300" r:id="rId8"/>
-    <p:sldId id="299" r:id="rId9"/>
-    <p:sldId id="303" r:id="rId10"/>
-    <p:sldId id="301" r:id="rId11"/>
-    <p:sldId id="302" r:id="rId12"/>
-    <p:sldId id="305" r:id="rId13"/>
-    <p:sldId id="307" r:id="rId14"/>
-    <p:sldId id="308" r:id="rId15"/>
-    <p:sldId id="311" r:id="rId16"/>
-    <p:sldId id="304" r:id="rId17"/>
-    <p:sldId id="309" r:id="rId18"/>
-    <p:sldId id="310" r:id="rId19"/>
+    <p:sldId id="312" r:id="rId6"/>
+    <p:sldId id="297" r:id="rId7"/>
+    <p:sldId id="298" r:id="rId8"/>
+    <p:sldId id="300" r:id="rId9"/>
+    <p:sldId id="299" r:id="rId10"/>
+    <p:sldId id="303" r:id="rId11"/>
+    <p:sldId id="301" r:id="rId12"/>
+    <p:sldId id="302" r:id="rId13"/>
+    <p:sldId id="305" r:id="rId14"/>
+    <p:sldId id="307" r:id="rId15"/>
+    <p:sldId id="308" r:id="rId16"/>
+    <p:sldId id="311" r:id="rId17"/>
+    <p:sldId id="304" r:id="rId18"/>
+    <p:sldId id="309" r:id="rId19"/>
+    <p:sldId id="310" r:id="rId20"/>
   </p:sldIdLst>
   <p:sldSz cx="9144000" cy="5143500" type="screen16x9"/>
   <p:notesSz cx="6858000" cy="9144000"/>
@@ -1101,7 +1102,7 @@
           <a:p>
             <a:fld id="{7A3E0868-4E26-4CDC-8A56-D70E2D8B12FE}" type="datetime3">
               <a:rPr lang="en-US" smtClean="0"/>
-              <a:t>20 March 2026</a:t>
+              <a:t>25 March 2026</a:t>
             </a:fld>
             <a:endParaRPr lang="en-US"/>
           </a:p>
@@ -3678,7 +3679,7 @@
           <a:p>
             <a:fld id="{A7B8021B-6105-4216-96FC-94348F216D0E}" type="datetime3">
               <a:rPr lang="en-US" smtClean="0"/>
-              <a:t>20 March 2026</a:t>
+              <a:t>25 March 2026</a:t>
             </a:fld>
             <a:endParaRPr lang="en-US"/>
           </a:p>
@@ -5376,7 +5377,7 @@
           <a:p>
             <a:fld id="{5D27CFAB-73E6-44A8-B862-B3306344E3F2}" type="datetime3">
               <a:rPr lang="en-US" smtClean="0"/>
-              <a:t>20 March 2026</a:t>
+              <a:t>25 March 2026</a:t>
             </a:fld>
             <a:endParaRPr lang="en-US"/>
           </a:p>
@@ -7167,7 +7168,7 @@
           <a:p>
             <a:fld id="{A9B2E784-A5F5-4301-881B-94AC8DBF9DED}" type="datetime3">
               <a:rPr lang="en-US" smtClean="0"/>
-              <a:t>20 March 2026</a:t>
+              <a:t>25 March 2026</a:t>
             </a:fld>
             <a:endParaRPr lang="en-US"/>
           </a:p>
@@ -7347,7 +7348,7 @@
           <a:p>
             <a:fld id="{18EAB3A5-9E92-4BB9-8F22-9632B4FBEDBA}" type="datetime3">
               <a:rPr lang="en-US" smtClean="0"/>
-              <a:t>20 March 2026</a:t>
+              <a:t>25 March 2026</a:t>
             </a:fld>
             <a:endParaRPr lang="en-US"/>
           </a:p>
@@ -7575,7 +7576,7 @@
           <a:p>
             <a:fld id="{40923810-5FB2-48C9-96CA-1DE2C4773142}" type="datetime3">
               <a:rPr lang="en-US" smtClean="0"/>
-              <a:t>20 March 2026</a:t>
+              <a:t>25 March 2026</a:t>
             </a:fld>
             <a:endParaRPr lang="en-US"/>
           </a:p>
@@ -7866,7 +7867,7 @@
           <a:p>
             <a:fld id="{E50EFF4B-86EB-42FB-93EA-7D8F9CB2466F}" type="datetime3">
               <a:rPr lang="en-US" smtClean="0"/>
-              <a:t>20 March 2026</a:t>
+              <a:t>25 March 2026</a:t>
             </a:fld>
             <a:endParaRPr lang="en-US"/>
           </a:p>
@@ -8479,7 +8480,7 @@
           <a:p>
             <a:fld id="{FB14FC24-E041-45E9-9A72-E5755A86890F}" type="datetime3">
               <a:rPr lang="en-US" smtClean="0"/>
-              <a:t>20 March 2026</a:t>
+              <a:t>25 March 2026</a:t>
             </a:fld>
             <a:endParaRPr lang="en-US"/>
           </a:p>
@@ -9340,7 +9341,7 @@
           <a:p>
             <a:fld id="{98A19125-94A7-4474-858C-FD9C4ABE9DDA}" type="datetime3">
               <a:rPr lang="en-US" smtClean="0"/>
-              <a:t>20 March 2026</a:t>
+              <a:t>25 March 2026</a:t>
             </a:fld>
             <a:endParaRPr lang="en-US"/>
           </a:p>
@@ -10444,7 +10445,7 @@
           <a:p>
             <a:fld id="{3BA0343D-C8D8-43CE-BB79-50DEA219DB07}" type="datetime3">
               <a:rPr lang="en-US" smtClean="0"/>
-              <a:t>20 March 2026</a:t>
+              <a:t>25 March 2026</a:t>
             </a:fld>
             <a:endParaRPr lang="en-US"/>
           </a:p>
@@ -10734,7 +10735,7 @@
           <a:p>
             <a:fld id="{453BD212-0B9F-4987-965F-AC83B2FC354F}" type="datetime3">
               <a:rPr lang="en-US" smtClean="0"/>
-              <a:t>20 March 2026</a:t>
+              <a:t>25 March 2026</a:t>
             </a:fld>
             <a:endParaRPr lang="en-US"/>
           </a:p>
@@ -10978,7 +10979,7 @@
           <a:p>
             <a:fld id="{6DDC931E-8CBE-4A3F-A034-9B6122C6DCDB}" type="datetime3">
               <a:rPr lang="en-US" smtClean="0"/>
-              <a:t>20 March 2026</a:t>
+              <a:t>25 March 2026</a:t>
             </a:fld>
             <a:endParaRPr lang="en-US"/>
           </a:p>
@@ -12761,7 +12762,7 @@
           <a:p>
             <a:fld id="{220AF9C2-5E8A-4308-AE6B-CA9B65007D0E}" type="datetime3">
               <a:rPr lang="en-US" smtClean="0"/>
-              <a:t>20 March 2026</a:t>
+              <a:t>25 March 2026</a:t>
             </a:fld>
             <a:endParaRPr lang="en-US"/>
           </a:p>
@@ -13075,7 +13076,7 @@
           <a:p>
             <a:fld id="{FF31E861-D2AF-431D-860B-DCF67C218052}" type="datetime3">
               <a:rPr lang="en-US" smtClean="0"/>
-              <a:t>20 March 2026</a:t>
+              <a:t>25 March 2026</a:t>
             </a:fld>
             <a:endParaRPr lang="en-US"/>
           </a:p>
@@ -13355,7 +13356,7 @@
           <a:p>
             <a:fld id="{D1DA25B2-AAF1-4C1F-AA38-12D5BFA7D4C8}" type="datetime3">
               <a:rPr lang="en-US" smtClean="0"/>
-              <a:t>20 March 2026</a:t>
+              <a:t>25 March 2026</a:t>
             </a:fld>
             <a:endParaRPr lang="en-US"/>
           </a:p>
@@ -13635,7 +13636,7 @@
           <a:p>
             <a:fld id="{A25C0F39-45D0-48E9-90B3-7FE8FCE561C8}" type="datetime3">
               <a:rPr lang="en-US" smtClean="0"/>
-              <a:t>20 March 2026</a:t>
+              <a:t>25 March 2026</a:t>
             </a:fld>
             <a:endParaRPr lang="en-US"/>
           </a:p>
@@ -14137,7 +14138,7 @@
           <a:p>
             <a:fld id="{9BAF1A3D-92FA-4F24-9781-74AFA516A230}" type="datetime3">
               <a:rPr lang="en-US" smtClean="0"/>
-              <a:t>20 March 2026</a:t>
+              <a:t>25 March 2026</a:t>
             </a:fld>
             <a:endParaRPr lang="en-US"/>
           </a:p>
@@ -14265,7 +14266,7 @@
           <a:p>
             <a:fld id="{5719C672-856D-4617-A693-8FE15749A9B7}" type="datetime3">
               <a:rPr lang="en-US" smtClean="0"/>
-              <a:t>20 March 2026</a:t>
+              <a:t>25 March 2026</a:t>
             </a:fld>
             <a:endParaRPr lang="en-US"/>
           </a:p>
@@ -14401,7 +14402,7 @@
           <a:p>
             <a:fld id="{5F6C764D-A39E-4C03-B161-E0BC66E8883B}" type="datetime3">
               <a:rPr lang="en-US" smtClean="0"/>
-              <a:t>20 March 2026</a:t>
+              <a:t>25 March 2026</a:t>
             </a:fld>
             <a:endParaRPr lang="en-US"/>
           </a:p>
@@ -14640,7 +14641,7 @@
           <a:p>
             <a:fld id="{6E3E33F9-20B7-4995-BE7D-165DBB597850}" type="datetime3">
               <a:rPr lang="en-US" smtClean="0"/>
-              <a:t>20 March 2026</a:t>
+              <a:t>25 March 2026</a:t>
             </a:fld>
             <a:endParaRPr lang="en-US"/>
           </a:p>
@@ -14754,7 +14755,7 @@
           <a:p>
             <a:fld id="{CD41C263-3501-4369-A962-62B6BF915CDE}" type="datetime3">
               <a:rPr lang="en-US" smtClean="0"/>
-              <a:t>20 March 2026</a:t>
+              <a:t>25 March 2026</a:t>
             </a:fld>
             <a:endParaRPr lang="en-US"/>
           </a:p>
@@ -15158,7 +15159,7 @@
           <a:p>
             <a:fld id="{B06F3EBE-B2E8-4992-9F00-9E4B44F057C0}" type="datetime3">
               <a:rPr lang="en-US" smtClean="0"/>
-              <a:t>20 March 2026</a:t>
+              <a:t>25 March 2026</a:t>
             </a:fld>
             <a:endParaRPr lang="en-US"/>
           </a:p>
@@ -15291,7 +15292,7 @@
           <a:p>
             <a:fld id="{D41656AB-D2E1-472E-8B95-0DF5C6E1D623}" type="datetime3">
               <a:rPr lang="en-US" smtClean="0"/>
-              <a:t>20 March 2026</a:t>
+              <a:t>25 March 2026</a:t>
             </a:fld>
             <a:endParaRPr lang="en-US"/>
           </a:p>
@@ -17199,7 +17200,7 @@
           <a:p>
             <a:fld id="{AD622D1A-DF83-41A8-85FF-04D90BF831D3}" type="datetime3">
               <a:rPr lang="en-US" smtClean="0"/>
-              <a:t>20 March 2026</a:t>
+              <a:t>25 March 2026</a:t>
             </a:fld>
             <a:endParaRPr lang="en-US"/>
           </a:p>
@@ -17450,7 +17451,7 @@
           <a:p>
             <a:fld id="{334F72C3-CDF3-44A8-B602-1649B1728485}" type="datetime3">
               <a:rPr lang="en-US" smtClean="0"/>
-              <a:t>20 March 2026</a:t>
+              <a:t>25 March 2026</a:t>
             </a:fld>
             <a:endParaRPr lang="en-US"/>
           </a:p>
@@ -17758,7 +17759,7 @@
           <a:p>
             <a:fld id="{1E0132BA-B5E7-4FFD-AF6C-169169D47D4A}" type="datetime3">
               <a:rPr lang="en-US" smtClean="0"/>
-              <a:t>20 March 2026</a:t>
+              <a:t>25 March 2026</a:t>
             </a:fld>
             <a:endParaRPr lang="en-US"/>
           </a:p>
@@ -18240,7 +18241,7 @@
           <a:p>
             <a:fld id="{81A30091-1C2A-4151-8D3C-D1E47A72615F}" type="datetime3">
               <a:rPr lang="en-US" smtClean="0"/>
-              <a:t>20 March 2026</a:t>
+              <a:t>25 March 2026</a:t>
             </a:fld>
             <a:endParaRPr lang="en-US"/>
           </a:p>
@@ -18878,7 +18879,7 @@
           <a:p>
             <a:fld id="{35D703CE-07B4-4C05-A488-B4566700621F}" type="datetime3">
               <a:rPr lang="en-US" smtClean="0"/>
-              <a:t>20 March 2026</a:t>
+              <a:t>25 March 2026</a:t>
             </a:fld>
             <a:endParaRPr lang="en-US"/>
           </a:p>
@@ -19937,7 +19938,7 @@
           <a:p>
             <a:fld id="{694BD61C-20BA-43AF-A21F-1DAFB3200099}" type="datetime3">
               <a:rPr lang="en-US" smtClean="0"/>
-              <a:t>20 March 2026</a:t>
+              <a:t>25 March 2026</a:t>
             </a:fld>
             <a:endParaRPr lang="en-US"/>
           </a:p>
@@ -20426,7 +20427,7 @@
           <a:p>
             <a:fld id="{CABCB1B0-B6E5-4DD1-BB55-95C076D6C0C8}" type="datetime3">
               <a:rPr lang="en-US" smtClean="0"/>
-              <a:t>20 March 2026</a:t>
+              <a:t>25 March 2026</a:t>
             </a:fld>
             <a:endParaRPr lang="en-US"/>
           </a:p>
@@ -20977,7 +20978,7 @@
           <a:p>
             <a:fld id="{7A3E0868-4E26-4CDC-8A56-D70E2D8B12FE}" type="datetime3">
               <a:rPr lang="en-US" smtClean="0"/>
-              <a:t>20 March 2026</a:t>
+              <a:t>25 March 2026</a:t>
             </a:fld>
             <a:endParaRPr lang="en-US"/>
           </a:p>
@@ -21355,6 +21356,1192 @@
 </file>
 
 <file path=ppt/slides/slide10.xml><?xml version="1.0" encoding="utf-8"?>
+<p:sld xmlns:a="http://schemas.openxmlformats.org/drawingml/2006/main" xmlns:r="http://schemas.openxmlformats.org/officeDocument/2006/relationships" xmlns:p="http://schemas.openxmlformats.org/presentationml/2006/main">
+  <p:cSld>
+    <p:spTree>
+      <p:nvGrpSpPr>
+        <p:cNvPr id="1" name=""/>
+        <p:cNvGrpSpPr/>
+        <p:nvPr/>
+      </p:nvGrpSpPr>
+      <p:grpSpPr>
+        <a:xfrm>
+          <a:off x="0" y="0"/>
+          <a:ext cx="0" cy="0"/>
+          <a:chOff x="0" y="0"/>
+          <a:chExt cx="0" cy="0"/>
+        </a:xfrm>
+      </p:grpSpPr>
+      <p:sp>
+        <p:nvSpPr>
+          <p:cNvPr id="2" name="Title 1">
+            <a:extLst>
+              <a:ext uri="{FF2B5EF4-FFF2-40B4-BE49-F238E27FC236}">
+                <a16:creationId xmlns:a16="http://schemas.microsoft.com/office/drawing/2014/main" id="{DEDB0583-9E7A-9535-B8F3-618E763A9746}"/>
+              </a:ext>
+            </a:extLst>
+          </p:cNvPr>
+          <p:cNvSpPr>
+            <a:spLocks noGrp="1"/>
+          </p:cNvSpPr>
+          <p:nvPr>
+            <p:ph type="title"/>
+          </p:nvPr>
+        </p:nvSpPr>
+        <p:spPr/>
+        <p:txBody>
+          <a:bodyPr/>
+          <a:lstStyle/>
+          <a:p>
+            <a:r>
+              <a:rPr lang="en-US" dirty="0"/>
+              <a:t>IPv4 Addressing – Reserved Addresses</a:t>
+            </a:r>
+          </a:p>
+        </p:txBody>
+      </p:sp>
+      <p:graphicFrame>
+        <p:nvGraphicFramePr>
+          <p:cNvPr id="8" name="Content Placeholder 7">
+            <a:extLst>
+              <a:ext uri="{FF2B5EF4-FFF2-40B4-BE49-F238E27FC236}">
+                <a16:creationId xmlns:a16="http://schemas.microsoft.com/office/drawing/2014/main" id="{5E94FF6C-B6DB-83B0-18FA-B1AE514D6C66}"/>
+              </a:ext>
+            </a:extLst>
+          </p:cNvPr>
+          <p:cNvGraphicFramePr>
+            <a:graphicFrameLocks noGrp="1"/>
+          </p:cNvGraphicFramePr>
+          <p:nvPr>
+            <p:ph sz="half" idx="2"/>
+            <p:extLst>
+              <p:ext uri="{D42A27DB-BD31-4B8C-83A1-F6EECF244321}">
+                <p14:modId xmlns:p14="http://schemas.microsoft.com/office/powerpoint/2010/main" val="2172834210"/>
+              </p:ext>
+            </p:extLst>
+          </p:nvPr>
+        </p:nvGraphicFramePr>
+        <p:xfrm>
+          <a:off x="2017876" y="1222997"/>
+          <a:ext cx="4475578" cy="3611892"/>
+        </p:xfrm>
+        <a:graphic>
+          <a:graphicData uri="http://schemas.openxmlformats.org/drawingml/2006/table">
+            <a:tbl>
+              <a:tblPr/>
+              <a:tblGrid>
+                <a:gridCol w="2237789">
+                  <a:extLst>
+                    <a:ext uri="{9D8B030D-6E8A-4147-A177-3AD203B41FA5}">
+                      <a16:colId xmlns:a16="http://schemas.microsoft.com/office/drawing/2014/main" val="2893615785"/>
+                    </a:ext>
+                  </a:extLst>
+                </a:gridCol>
+                <a:gridCol w="2237789">
+                  <a:extLst>
+                    <a:ext uri="{9D8B030D-6E8A-4147-A177-3AD203B41FA5}">
+                      <a16:colId xmlns:a16="http://schemas.microsoft.com/office/drawing/2014/main" val="3977585347"/>
+                    </a:ext>
+                  </a:extLst>
+                </a:gridCol>
+              </a:tblGrid>
+              <a:tr h="244929">
+                <a:tc>
+                  <a:txBody>
+                    <a:bodyPr/>
+                    <a:lstStyle/>
+                    <a:p>
+                      <a:pPr>
+                        <a:buNone/>
+                      </a:pPr>
+                      <a:r>
+                        <a:rPr lang="en-US" sz="1100" b="1" dirty="0"/>
+                        <a:t>Network Range</a:t>
+                      </a:r>
+                    </a:p>
+                  </a:txBody>
+                  <a:tcPr marL="78377" marR="78377" marT="39189" marB="39189" anchor="ctr">
+                    <a:lnL>
+                      <a:noFill/>
+                    </a:lnL>
+                    <a:lnR>
+                      <a:noFill/>
+                    </a:lnR>
+                    <a:lnT>
+                      <a:noFill/>
+                    </a:lnT>
+                    <a:lnB>
+                      <a:noFill/>
+                    </a:lnB>
+                    <a:noFill/>
+                  </a:tcPr>
+                </a:tc>
+                <a:tc>
+                  <a:txBody>
+                    <a:bodyPr/>
+                    <a:lstStyle/>
+                    <a:p>
+                      <a:pPr>
+                        <a:buNone/>
+                      </a:pPr>
+                      <a:r>
+                        <a:rPr lang="en-US" sz="1100" b="1" dirty="0"/>
+                        <a:t>Purpose</a:t>
+                      </a:r>
+                    </a:p>
+                  </a:txBody>
+                  <a:tcPr marL="78377" marR="78377" marT="39189" marB="39189" anchor="ctr">
+                    <a:lnL>
+                      <a:noFill/>
+                    </a:lnL>
+                    <a:lnR>
+                      <a:noFill/>
+                    </a:lnR>
+                    <a:lnT>
+                      <a:noFill/>
+                    </a:lnT>
+                    <a:lnB>
+                      <a:noFill/>
+                    </a:lnB>
+                    <a:noFill/>
+                  </a:tcPr>
+                </a:tc>
+                <a:extLst>
+                  <a:ext uri="{0D108BD9-81ED-4DB2-BD59-A6C34878D82A}">
+                    <a16:rowId xmlns:a16="http://schemas.microsoft.com/office/drawing/2014/main" val="3385045340"/>
+                  </a:ext>
+                </a:extLst>
+              </a:tr>
+              <a:tr h="244929">
+                <a:tc>
+                  <a:txBody>
+                    <a:bodyPr/>
+                    <a:lstStyle/>
+                    <a:p>
+                      <a:pPr>
+                        <a:buNone/>
+                      </a:pPr>
+                      <a:r>
+                        <a:rPr lang="en-US" sz="1100" dirty="0">
+                          <a:latin typeface="Courier New" panose="02070309020205020404" pitchFamily="49" charset="0"/>
+                        </a:rPr>
+                        <a:t>0.0.0.0/8</a:t>
+                      </a:r>
+                      <a:endParaRPr lang="en-US" sz="1100" dirty="0"/>
+                    </a:p>
+                  </a:txBody>
+                  <a:tcPr marL="78377" marR="78377" marT="39189" marB="39189" anchor="ctr">
+                    <a:lnL>
+                      <a:noFill/>
+                    </a:lnL>
+                    <a:lnR>
+                      <a:noFill/>
+                    </a:lnR>
+                    <a:lnT>
+                      <a:noFill/>
+                    </a:lnT>
+                    <a:lnB>
+                      <a:noFill/>
+                    </a:lnB>
+                    <a:noFill/>
+                  </a:tcPr>
+                </a:tc>
+                <a:tc>
+                  <a:txBody>
+                    <a:bodyPr/>
+                    <a:lstStyle/>
+                    <a:p>
+                      <a:pPr>
+                        <a:buNone/>
+                      </a:pPr>
+                      <a:r>
+                        <a:rPr lang="en-US" sz="1100" dirty="0"/>
+                        <a:t>Network identification, default routes</a:t>
+                      </a:r>
+                    </a:p>
+                  </a:txBody>
+                  <a:tcPr marL="78377" marR="78377" marT="39189" marB="39189" anchor="ctr">
+                    <a:lnL>
+                      <a:noFill/>
+                    </a:lnL>
+                    <a:lnR>
+                      <a:noFill/>
+                    </a:lnR>
+                    <a:lnT>
+                      <a:noFill/>
+                    </a:lnT>
+                    <a:lnB>
+                      <a:noFill/>
+                    </a:lnB>
+                    <a:noFill/>
+                  </a:tcPr>
+                </a:tc>
+                <a:extLst>
+                  <a:ext uri="{0D108BD9-81ED-4DB2-BD59-A6C34878D82A}">
+                    <a16:rowId xmlns:a16="http://schemas.microsoft.com/office/drawing/2014/main" val="3800661372"/>
+                  </a:ext>
+                </a:extLst>
+              </a:tr>
+              <a:tr h="244929">
+                <a:tc>
+                  <a:txBody>
+                    <a:bodyPr/>
+                    <a:lstStyle/>
+                    <a:p>
+                      <a:pPr>
+                        <a:buNone/>
+                      </a:pPr>
+                      <a:r>
+                        <a:rPr lang="en-US" sz="1100">
+                          <a:latin typeface="Courier New" panose="02070309020205020404" pitchFamily="49" charset="0"/>
+                        </a:rPr>
+                        <a:t>10.0.0.0/8</a:t>
+                      </a:r>
+                      <a:endParaRPr lang="en-US" sz="1100"/>
+                    </a:p>
+                  </a:txBody>
+                  <a:tcPr marL="78377" marR="78377" marT="39189" marB="39189" anchor="ctr">
+                    <a:lnL>
+                      <a:noFill/>
+                    </a:lnL>
+                    <a:lnR>
+                      <a:noFill/>
+                    </a:lnR>
+                    <a:lnT>
+                      <a:noFill/>
+                    </a:lnT>
+                    <a:lnB>
+                      <a:noFill/>
+                    </a:lnB>
+                    <a:solidFill>
+                      <a:schemeClr val="bg2">
+                        <a:lumMod val="60000"/>
+                        <a:lumOff val="40000"/>
+                      </a:schemeClr>
+                    </a:solidFill>
+                  </a:tcPr>
+                </a:tc>
+                <a:tc>
+                  <a:txBody>
+                    <a:bodyPr/>
+                    <a:lstStyle/>
+                    <a:p>
+                      <a:pPr>
+                        <a:buNone/>
+                      </a:pPr>
+                      <a:r>
+                        <a:rPr lang="en-US" sz="1100" dirty="0">
+                          <a:highlight>
+                            <a:srgbClr val="FFFF00"/>
+                          </a:highlight>
+                        </a:rPr>
+                        <a:t>Private</a:t>
+                      </a:r>
+                      <a:r>
+                        <a:rPr lang="en-US" sz="1100" dirty="0"/>
+                        <a:t> networks (RFC 1918)</a:t>
+                      </a:r>
+                    </a:p>
+                  </a:txBody>
+                  <a:tcPr marL="78377" marR="78377" marT="39189" marB="39189" anchor="ctr">
+                    <a:lnL>
+                      <a:noFill/>
+                    </a:lnL>
+                    <a:lnR>
+                      <a:noFill/>
+                    </a:lnR>
+                    <a:lnT>
+                      <a:noFill/>
+                    </a:lnT>
+                    <a:lnB>
+                      <a:noFill/>
+                    </a:lnB>
+                    <a:solidFill>
+                      <a:schemeClr val="bg2">
+                        <a:lumMod val="60000"/>
+                        <a:lumOff val="40000"/>
+                      </a:schemeClr>
+                    </a:solidFill>
+                  </a:tcPr>
+                </a:tc>
+                <a:extLst>
+                  <a:ext uri="{0D108BD9-81ED-4DB2-BD59-A6C34878D82A}">
+                    <a16:rowId xmlns:a16="http://schemas.microsoft.com/office/drawing/2014/main" val="4259145204"/>
+                  </a:ext>
+                </a:extLst>
+              </a:tr>
+              <a:tr h="244929">
+                <a:tc>
+                  <a:txBody>
+                    <a:bodyPr/>
+                    <a:lstStyle/>
+                    <a:p>
+                      <a:pPr>
+                        <a:buNone/>
+                      </a:pPr>
+                      <a:r>
+                        <a:rPr lang="en-US" sz="1100">
+                          <a:latin typeface="Courier New" panose="02070309020205020404" pitchFamily="49" charset="0"/>
+                        </a:rPr>
+                        <a:t>100.64.0.0/10</a:t>
+                      </a:r>
+                      <a:endParaRPr lang="en-US" sz="1100"/>
+                    </a:p>
+                  </a:txBody>
+                  <a:tcPr marL="78377" marR="78377" marT="39189" marB="39189" anchor="ctr">
+                    <a:lnL>
+                      <a:noFill/>
+                    </a:lnL>
+                    <a:lnR>
+                      <a:noFill/>
+                    </a:lnR>
+                    <a:lnT>
+                      <a:noFill/>
+                    </a:lnT>
+                    <a:lnB>
+                      <a:noFill/>
+                    </a:lnB>
+                    <a:noFill/>
+                  </a:tcPr>
+                </a:tc>
+                <a:tc>
+                  <a:txBody>
+                    <a:bodyPr/>
+                    <a:lstStyle/>
+                    <a:p>
+                      <a:pPr>
+                        <a:buNone/>
+                      </a:pPr>
+                      <a:r>
+                        <a:rPr lang="en-US" sz="1100" dirty="0"/>
+                        <a:t>Carrier-grade NAT (CGNAT)</a:t>
+                      </a:r>
+                    </a:p>
+                  </a:txBody>
+                  <a:tcPr marL="78377" marR="78377" marT="39189" marB="39189" anchor="ctr">
+                    <a:lnL>
+                      <a:noFill/>
+                    </a:lnL>
+                    <a:lnR>
+                      <a:noFill/>
+                    </a:lnR>
+                    <a:lnT>
+                      <a:noFill/>
+                    </a:lnT>
+                    <a:lnB>
+                      <a:noFill/>
+                    </a:lnB>
+                    <a:noFill/>
+                  </a:tcPr>
+                </a:tc>
+                <a:extLst>
+                  <a:ext uri="{0D108BD9-81ED-4DB2-BD59-A6C34878D82A}">
+                    <a16:rowId xmlns:a16="http://schemas.microsoft.com/office/drawing/2014/main" val="3521821730"/>
+                  </a:ext>
+                </a:extLst>
+              </a:tr>
+              <a:tr h="244929">
+                <a:tc>
+                  <a:txBody>
+                    <a:bodyPr/>
+                    <a:lstStyle/>
+                    <a:p>
+                      <a:pPr>
+                        <a:buNone/>
+                      </a:pPr>
+                      <a:r>
+                        <a:rPr lang="en-US" sz="1100" dirty="0">
+                          <a:latin typeface="Courier New" panose="02070309020205020404" pitchFamily="49" charset="0"/>
+                        </a:rPr>
+                        <a:t>127.0.0.0/8</a:t>
+                      </a:r>
+                      <a:endParaRPr lang="en-US" sz="1100" dirty="0"/>
+                    </a:p>
+                  </a:txBody>
+                  <a:tcPr marL="78377" marR="78377" marT="39189" marB="39189" anchor="ctr">
+                    <a:lnL>
+                      <a:noFill/>
+                    </a:lnL>
+                    <a:lnR>
+                      <a:noFill/>
+                    </a:lnR>
+                    <a:lnT>
+                      <a:noFill/>
+                    </a:lnT>
+                    <a:lnB>
+                      <a:noFill/>
+                    </a:lnB>
+                    <a:solidFill>
+                      <a:schemeClr val="bg2">
+                        <a:lumMod val="60000"/>
+                        <a:lumOff val="40000"/>
+                      </a:schemeClr>
+                    </a:solidFill>
+                  </a:tcPr>
+                </a:tc>
+                <a:tc>
+                  <a:txBody>
+                    <a:bodyPr/>
+                    <a:lstStyle/>
+                    <a:p>
+                      <a:pPr>
+                        <a:buNone/>
+                      </a:pPr>
+                      <a:r>
+                        <a:rPr lang="en-US" sz="1100" dirty="0">
+                          <a:highlight>
+                            <a:srgbClr val="FFFF00"/>
+                          </a:highlight>
+                        </a:rPr>
+                        <a:t>Loopback</a:t>
+                      </a:r>
+                      <a:r>
+                        <a:rPr lang="en-US" sz="1100" dirty="0"/>
+                        <a:t> (localhost)</a:t>
+                      </a:r>
+                    </a:p>
+                  </a:txBody>
+                  <a:tcPr marL="78377" marR="78377" marT="39189" marB="39189" anchor="ctr">
+                    <a:lnL>
+                      <a:noFill/>
+                    </a:lnL>
+                    <a:lnR>
+                      <a:noFill/>
+                    </a:lnR>
+                    <a:lnT>
+                      <a:noFill/>
+                    </a:lnT>
+                    <a:lnB>
+                      <a:noFill/>
+                    </a:lnB>
+                    <a:solidFill>
+                      <a:schemeClr val="bg2">
+                        <a:lumMod val="60000"/>
+                        <a:lumOff val="40000"/>
+                      </a:schemeClr>
+                    </a:solidFill>
+                  </a:tcPr>
+                </a:tc>
+                <a:extLst>
+                  <a:ext uri="{0D108BD9-81ED-4DB2-BD59-A6C34878D82A}">
+                    <a16:rowId xmlns:a16="http://schemas.microsoft.com/office/drawing/2014/main" val="3354651175"/>
+                  </a:ext>
+                </a:extLst>
+              </a:tr>
+              <a:tr h="244929">
+                <a:tc>
+                  <a:txBody>
+                    <a:bodyPr/>
+                    <a:lstStyle/>
+                    <a:p>
+                      <a:pPr>
+                        <a:buNone/>
+                      </a:pPr>
+                      <a:r>
+                        <a:rPr lang="en-US" sz="1100">
+                          <a:latin typeface="Courier New" panose="02070309020205020404" pitchFamily="49" charset="0"/>
+                        </a:rPr>
+                        <a:t>169.254.0.0/16</a:t>
+                      </a:r>
+                      <a:endParaRPr lang="en-US" sz="1100"/>
+                    </a:p>
+                  </a:txBody>
+                  <a:tcPr marL="78377" marR="78377" marT="39189" marB="39189" anchor="ctr">
+                    <a:lnL>
+                      <a:noFill/>
+                    </a:lnL>
+                    <a:lnR>
+                      <a:noFill/>
+                    </a:lnR>
+                    <a:lnT>
+                      <a:noFill/>
+                    </a:lnT>
+                    <a:lnB>
+                      <a:noFill/>
+                    </a:lnB>
+                    <a:solidFill>
+                      <a:schemeClr val="bg2">
+                        <a:lumMod val="60000"/>
+                        <a:lumOff val="40000"/>
+                      </a:schemeClr>
+                    </a:solidFill>
+                  </a:tcPr>
+                </a:tc>
+                <a:tc>
+                  <a:txBody>
+                    <a:bodyPr/>
+                    <a:lstStyle/>
+                    <a:p>
+                      <a:pPr>
+                        <a:buNone/>
+                      </a:pPr>
+                      <a:r>
+                        <a:rPr lang="en-US" sz="1100" dirty="0"/>
+                        <a:t>Link-local (APIPA)</a:t>
+                      </a:r>
+                    </a:p>
+                  </a:txBody>
+                  <a:tcPr marL="78377" marR="78377" marT="39189" marB="39189" anchor="ctr">
+                    <a:lnL>
+                      <a:noFill/>
+                    </a:lnL>
+                    <a:lnR>
+                      <a:noFill/>
+                    </a:lnR>
+                    <a:lnT>
+                      <a:noFill/>
+                    </a:lnT>
+                    <a:lnB>
+                      <a:noFill/>
+                    </a:lnB>
+                    <a:solidFill>
+                      <a:schemeClr val="bg2">
+                        <a:lumMod val="60000"/>
+                        <a:lumOff val="40000"/>
+                      </a:schemeClr>
+                    </a:solidFill>
+                  </a:tcPr>
+                </a:tc>
+                <a:extLst>
+                  <a:ext uri="{0D108BD9-81ED-4DB2-BD59-A6C34878D82A}">
+                    <a16:rowId xmlns:a16="http://schemas.microsoft.com/office/drawing/2014/main" val="1054555260"/>
+                  </a:ext>
+                </a:extLst>
+              </a:tr>
+              <a:tr h="244929">
+                <a:tc>
+                  <a:txBody>
+                    <a:bodyPr/>
+                    <a:lstStyle/>
+                    <a:p>
+                      <a:pPr>
+                        <a:buNone/>
+                      </a:pPr>
+                      <a:r>
+                        <a:rPr lang="en-US" sz="1100" dirty="0">
+                          <a:latin typeface="Courier New" panose="02070309020205020404" pitchFamily="49" charset="0"/>
+                        </a:rPr>
+                        <a:t>172.16.0.0/12</a:t>
+                      </a:r>
+                      <a:endParaRPr lang="en-US" sz="1100" dirty="0"/>
+                    </a:p>
+                  </a:txBody>
+                  <a:tcPr marL="78377" marR="78377" marT="39189" marB="39189" anchor="ctr">
+                    <a:lnL>
+                      <a:noFill/>
+                    </a:lnL>
+                    <a:lnR>
+                      <a:noFill/>
+                    </a:lnR>
+                    <a:lnT>
+                      <a:noFill/>
+                    </a:lnT>
+                    <a:lnB>
+                      <a:noFill/>
+                    </a:lnB>
+                    <a:solidFill>
+                      <a:schemeClr val="bg2">
+                        <a:lumMod val="60000"/>
+                        <a:lumOff val="40000"/>
+                      </a:schemeClr>
+                    </a:solidFill>
+                  </a:tcPr>
+                </a:tc>
+                <a:tc>
+                  <a:txBody>
+                    <a:bodyPr/>
+                    <a:lstStyle/>
+                    <a:p>
+                      <a:pPr>
+                        <a:buNone/>
+                      </a:pPr>
+                      <a:r>
+                        <a:rPr lang="en-US" sz="1100" dirty="0">
+                          <a:highlight>
+                            <a:srgbClr val="FFFF00"/>
+                          </a:highlight>
+                        </a:rPr>
+                        <a:t>Private</a:t>
+                      </a:r>
+                      <a:r>
+                        <a:rPr lang="en-US" sz="1100" dirty="0"/>
+                        <a:t> networks (RFC 1918)</a:t>
+                      </a:r>
+                    </a:p>
+                  </a:txBody>
+                  <a:tcPr marL="78377" marR="78377" marT="39189" marB="39189" anchor="ctr">
+                    <a:lnL>
+                      <a:noFill/>
+                    </a:lnL>
+                    <a:lnR>
+                      <a:noFill/>
+                    </a:lnR>
+                    <a:lnT>
+                      <a:noFill/>
+                    </a:lnT>
+                    <a:lnB>
+                      <a:noFill/>
+                    </a:lnB>
+                    <a:solidFill>
+                      <a:schemeClr val="bg2">
+                        <a:lumMod val="60000"/>
+                        <a:lumOff val="40000"/>
+                      </a:schemeClr>
+                    </a:solidFill>
+                  </a:tcPr>
+                </a:tc>
+                <a:extLst>
+                  <a:ext uri="{0D108BD9-81ED-4DB2-BD59-A6C34878D82A}">
+                    <a16:rowId xmlns:a16="http://schemas.microsoft.com/office/drawing/2014/main" val="1296967149"/>
+                  </a:ext>
+                </a:extLst>
+              </a:tr>
+              <a:tr h="244929">
+                <a:tc>
+                  <a:txBody>
+                    <a:bodyPr/>
+                    <a:lstStyle/>
+                    <a:p>
+                      <a:pPr>
+                        <a:buNone/>
+                      </a:pPr>
+                      <a:r>
+                        <a:rPr lang="en-US" sz="1100">
+                          <a:latin typeface="Courier New" panose="02070309020205020404" pitchFamily="49" charset="0"/>
+                        </a:rPr>
+                        <a:t>192.0.0.0/24</a:t>
+                      </a:r>
+                      <a:endParaRPr lang="en-US" sz="1100"/>
+                    </a:p>
+                  </a:txBody>
+                  <a:tcPr marL="78377" marR="78377" marT="39189" marB="39189" anchor="ctr">
+                    <a:lnL>
+                      <a:noFill/>
+                    </a:lnL>
+                    <a:lnR>
+                      <a:noFill/>
+                    </a:lnR>
+                    <a:lnT>
+                      <a:noFill/>
+                    </a:lnT>
+                    <a:lnB>
+                      <a:noFill/>
+                    </a:lnB>
+                    <a:noFill/>
+                  </a:tcPr>
+                </a:tc>
+                <a:tc>
+                  <a:txBody>
+                    <a:bodyPr/>
+                    <a:lstStyle/>
+                    <a:p>
+                      <a:pPr>
+                        <a:buNone/>
+                      </a:pPr>
+                      <a:r>
+                        <a:rPr lang="en-US" sz="1100"/>
+                        <a:t>IETF Protocol Assignments</a:t>
+                      </a:r>
+                    </a:p>
+                  </a:txBody>
+                  <a:tcPr marL="78377" marR="78377" marT="39189" marB="39189" anchor="ctr">
+                    <a:lnL>
+                      <a:noFill/>
+                    </a:lnL>
+                    <a:lnR>
+                      <a:noFill/>
+                    </a:lnR>
+                    <a:lnT>
+                      <a:noFill/>
+                    </a:lnT>
+                    <a:lnB>
+                      <a:noFill/>
+                    </a:lnB>
+                    <a:noFill/>
+                  </a:tcPr>
+                </a:tc>
+                <a:extLst>
+                  <a:ext uri="{0D108BD9-81ED-4DB2-BD59-A6C34878D82A}">
+                    <a16:rowId xmlns:a16="http://schemas.microsoft.com/office/drawing/2014/main" val="18452452"/>
+                  </a:ext>
+                </a:extLst>
+              </a:tr>
+              <a:tr h="244929">
+                <a:tc>
+                  <a:txBody>
+                    <a:bodyPr/>
+                    <a:lstStyle/>
+                    <a:p>
+                      <a:pPr>
+                        <a:buNone/>
+                      </a:pPr>
+                      <a:r>
+                        <a:rPr lang="en-US" sz="1100" dirty="0">
+                          <a:latin typeface="Courier New" panose="02070309020205020404" pitchFamily="49" charset="0"/>
+                        </a:rPr>
+                        <a:t>192.168.0.0/16</a:t>
+                      </a:r>
+                      <a:endParaRPr lang="en-US" sz="1100" dirty="0"/>
+                    </a:p>
+                  </a:txBody>
+                  <a:tcPr marL="78377" marR="78377" marT="39189" marB="39189" anchor="ctr">
+                    <a:lnL>
+                      <a:noFill/>
+                    </a:lnL>
+                    <a:lnR>
+                      <a:noFill/>
+                    </a:lnR>
+                    <a:lnT>
+                      <a:noFill/>
+                    </a:lnT>
+                    <a:lnB>
+                      <a:noFill/>
+                    </a:lnB>
+                    <a:solidFill>
+                      <a:schemeClr val="bg2">
+                        <a:lumMod val="60000"/>
+                        <a:lumOff val="40000"/>
+                      </a:schemeClr>
+                    </a:solidFill>
+                  </a:tcPr>
+                </a:tc>
+                <a:tc>
+                  <a:txBody>
+                    <a:bodyPr/>
+                    <a:lstStyle/>
+                    <a:p>
+                      <a:pPr>
+                        <a:buNone/>
+                      </a:pPr>
+                      <a:r>
+                        <a:rPr lang="en-US" sz="1100" dirty="0">
+                          <a:highlight>
+                            <a:srgbClr val="FFFF00"/>
+                          </a:highlight>
+                        </a:rPr>
+                        <a:t>Private</a:t>
+                      </a:r>
+                      <a:r>
+                        <a:rPr lang="en-US" sz="1100" dirty="0"/>
+                        <a:t> networks (RFC 1918)</a:t>
+                      </a:r>
+                    </a:p>
+                  </a:txBody>
+                  <a:tcPr marL="78377" marR="78377" marT="39189" marB="39189" anchor="ctr">
+                    <a:lnL>
+                      <a:noFill/>
+                    </a:lnL>
+                    <a:lnR>
+                      <a:noFill/>
+                    </a:lnR>
+                    <a:lnT>
+                      <a:noFill/>
+                    </a:lnT>
+                    <a:lnB>
+                      <a:noFill/>
+                    </a:lnB>
+                    <a:solidFill>
+                      <a:schemeClr val="bg2">
+                        <a:lumMod val="60000"/>
+                        <a:lumOff val="40000"/>
+                      </a:schemeClr>
+                    </a:solidFill>
+                  </a:tcPr>
+                </a:tc>
+                <a:extLst>
+                  <a:ext uri="{0D108BD9-81ED-4DB2-BD59-A6C34878D82A}">
+                    <a16:rowId xmlns:a16="http://schemas.microsoft.com/office/drawing/2014/main" val="503910929"/>
+                  </a:ext>
+                </a:extLst>
+              </a:tr>
+              <a:tr h="244929">
+                <a:tc>
+                  <a:txBody>
+                    <a:bodyPr/>
+                    <a:lstStyle/>
+                    <a:p>
+                      <a:pPr>
+                        <a:buNone/>
+                      </a:pPr>
+                      <a:r>
+                        <a:rPr lang="en-US" sz="1100">
+                          <a:latin typeface="Courier New" panose="02070309020205020404" pitchFamily="49" charset="0"/>
+                        </a:rPr>
+                        <a:t>192.88.99.0/24</a:t>
+                      </a:r>
+                      <a:endParaRPr lang="en-US" sz="1100"/>
+                    </a:p>
+                  </a:txBody>
+                  <a:tcPr marL="78377" marR="78377" marT="39189" marB="39189" anchor="ctr">
+                    <a:lnL>
+                      <a:noFill/>
+                    </a:lnL>
+                    <a:lnR>
+                      <a:noFill/>
+                    </a:lnR>
+                    <a:lnT>
+                      <a:noFill/>
+                    </a:lnT>
+                    <a:lnB>
+                      <a:noFill/>
+                    </a:lnB>
+                    <a:noFill/>
+                  </a:tcPr>
+                </a:tc>
+                <a:tc>
+                  <a:txBody>
+                    <a:bodyPr/>
+                    <a:lstStyle/>
+                    <a:p>
+                      <a:pPr>
+                        <a:buNone/>
+                      </a:pPr>
+                      <a:r>
+                        <a:rPr lang="en-US" sz="1100"/>
+                        <a:t>IPv6-to-IPv4 relay (deprecated)</a:t>
+                      </a:r>
+                    </a:p>
+                  </a:txBody>
+                  <a:tcPr marL="78377" marR="78377" marT="39189" marB="39189" anchor="ctr">
+                    <a:lnL>
+                      <a:noFill/>
+                    </a:lnL>
+                    <a:lnR>
+                      <a:noFill/>
+                    </a:lnR>
+                    <a:lnT>
+                      <a:noFill/>
+                    </a:lnT>
+                    <a:lnB>
+                      <a:noFill/>
+                    </a:lnB>
+                    <a:noFill/>
+                  </a:tcPr>
+                </a:tc>
+                <a:extLst>
+                  <a:ext uri="{0D108BD9-81ED-4DB2-BD59-A6C34878D82A}">
+                    <a16:rowId xmlns:a16="http://schemas.microsoft.com/office/drawing/2014/main" val="1535487904"/>
+                  </a:ext>
+                </a:extLst>
+              </a:tr>
+              <a:tr h="244929">
+                <a:tc>
+                  <a:txBody>
+                    <a:bodyPr/>
+                    <a:lstStyle/>
+                    <a:p>
+                      <a:pPr>
+                        <a:buNone/>
+                      </a:pPr>
+                      <a:r>
+                        <a:rPr lang="en-US" sz="1100">
+                          <a:latin typeface="Courier New" panose="02070309020205020404" pitchFamily="49" charset="0"/>
+                        </a:rPr>
+                        <a:t>198.18.0.0/15</a:t>
+                      </a:r>
+                      <a:endParaRPr lang="en-US" sz="1100"/>
+                    </a:p>
+                  </a:txBody>
+                  <a:tcPr marL="78377" marR="78377" marT="39189" marB="39189" anchor="ctr">
+                    <a:lnL>
+                      <a:noFill/>
+                    </a:lnL>
+                    <a:lnR>
+                      <a:noFill/>
+                    </a:lnR>
+                    <a:lnT>
+                      <a:noFill/>
+                    </a:lnT>
+                    <a:lnB>
+                      <a:noFill/>
+                    </a:lnB>
+                    <a:noFill/>
+                  </a:tcPr>
+                </a:tc>
+                <a:tc>
+                  <a:txBody>
+                    <a:bodyPr/>
+                    <a:lstStyle/>
+                    <a:p>
+                      <a:pPr>
+                        <a:buNone/>
+                      </a:pPr>
+                      <a:r>
+                        <a:rPr lang="en-US" sz="1100"/>
+                        <a:t>Network benchmark testing</a:t>
+                      </a:r>
+                    </a:p>
+                  </a:txBody>
+                  <a:tcPr marL="78377" marR="78377" marT="39189" marB="39189" anchor="ctr">
+                    <a:lnL>
+                      <a:noFill/>
+                    </a:lnL>
+                    <a:lnR>
+                      <a:noFill/>
+                    </a:lnR>
+                    <a:lnT>
+                      <a:noFill/>
+                    </a:lnT>
+                    <a:lnB>
+                      <a:noFill/>
+                    </a:lnB>
+                    <a:noFill/>
+                  </a:tcPr>
+                </a:tc>
+                <a:extLst>
+                  <a:ext uri="{0D108BD9-81ED-4DB2-BD59-A6C34878D82A}">
+                    <a16:rowId xmlns:a16="http://schemas.microsoft.com/office/drawing/2014/main" val="3723439859"/>
+                  </a:ext>
+                </a:extLst>
+              </a:tr>
+              <a:tr h="244929">
+                <a:tc>
+                  <a:txBody>
+                    <a:bodyPr/>
+                    <a:lstStyle/>
+                    <a:p>
+                      <a:pPr>
+                        <a:buNone/>
+                      </a:pPr>
+                      <a:r>
+                        <a:rPr lang="en-US" sz="1100" dirty="0">
+                          <a:latin typeface="Courier New" panose="02070309020205020404" pitchFamily="49" charset="0"/>
+                        </a:rPr>
+                        <a:t>224.0.0.0/4</a:t>
+                      </a:r>
+                      <a:endParaRPr lang="en-US" sz="1100" dirty="0"/>
+                    </a:p>
+                  </a:txBody>
+                  <a:tcPr marL="78377" marR="78377" marT="39189" marB="39189" anchor="ctr">
+                    <a:lnL>
+                      <a:noFill/>
+                    </a:lnL>
+                    <a:lnR>
+                      <a:noFill/>
+                    </a:lnR>
+                    <a:lnT>
+                      <a:noFill/>
+                    </a:lnT>
+                    <a:lnB>
+                      <a:noFill/>
+                    </a:lnB>
+                    <a:solidFill>
+                      <a:schemeClr val="bg2">
+                        <a:lumMod val="60000"/>
+                        <a:lumOff val="40000"/>
+                      </a:schemeClr>
+                    </a:solidFill>
+                  </a:tcPr>
+                </a:tc>
+                <a:tc>
+                  <a:txBody>
+                    <a:bodyPr/>
+                    <a:lstStyle/>
+                    <a:p>
+                      <a:pPr>
+                        <a:buNone/>
+                      </a:pPr>
+                      <a:r>
+                        <a:rPr lang="en-US" sz="1100" dirty="0"/>
+                        <a:t>Multicast addresses</a:t>
+                      </a:r>
+                    </a:p>
+                  </a:txBody>
+                  <a:tcPr marL="78377" marR="78377" marT="39189" marB="39189" anchor="ctr">
+                    <a:lnL>
+                      <a:noFill/>
+                    </a:lnL>
+                    <a:lnR>
+                      <a:noFill/>
+                    </a:lnR>
+                    <a:lnT>
+                      <a:noFill/>
+                    </a:lnT>
+                    <a:lnB>
+                      <a:noFill/>
+                    </a:lnB>
+                    <a:solidFill>
+                      <a:schemeClr val="bg2">
+                        <a:lumMod val="60000"/>
+                        <a:lumOff val="40000"/>
+                      </a:schemeClr>
+                    </a:solidFill>
+                  </a:tcPr>
+                </a:tc>
+                <a:extLst>
+                  <a:ext uri="{0D108BD9-81ED-4DB2-BD59-A6C34878D82A}">
+                    <a16:rowId xmlns:a16="http://schemas.microsoft.com/office/drawing/2014/main" val="3207159718"/>
+                  </a:ext>
+                </a:extLst>
+              </a:tr>
+              <a:tr h="244929">
+                <a:tc>
+                  <a:txBody>
+                    <a:bodyPr/>
+                    <a:lstStyle/>
+                    <a:p>
+                      <a:pPr>
+                        <a:buNone/>
+                      </a:pPr>
+                      <a:r>
+                        <a:rPr lang="en-US" sz="1100">
+                          <a:latin typeface="Courier New" panose="02070309020205020404" pitchFamily="49" charset="0"/>
+                        </a:rPr>
+                        <a:t>240.0.0.0/4</a:t>
+                      </a:r>
+                      <a:endParaRPr lang="en-US" sz="1100"/>
+                    </a:p>
+                  </a:txBody>
+                  <a:tcPr marL="78377" marR="78377" marT="39189" marB="39189" anchor="ctr">
+                    <a:lnL>
+                      <a:noFill/>
+                    </a:lnL>
+                    <a:lnR>
+                      <a:noFill/>
+                    </a:lnR>
+                    <a:lnT>
+                      <a:noFill/>
+                    </a:lnT>
+                    <a:lnB>
+                      <a:noFill/>
+                    </a:lnB>
+                    <a:noFill/>
+                  </a:tcPr>
+                </a:tc>
+                <a:tc>
+                  <a:txBody>
+                    <a:bodyPr/>
+                    <a:lstStyle/>
+                    <a:p>
+                      <a:pPr>
+                        <a:buNone/>
+                      </a:pPr>
+                      <a:r>
+                        <a:rPr lang="en-US" sz="1100"/>
+                        <a:t>Reserved for future use</a:t>
+                      </a:r>
+                    </a:p>
+                  </a:txBody>
+                  <a:tcPr marL="78377" marR="78377" marT="39189" marB="39189" anchor="ctr">
+                    <a:lnL>
+                      <a:noFill/>
+                    </a:lnL>
+                    <a:lnR>
+                      <a:noFill/>
+                    </a:lnR>
+                    <a:lnT>
+                      <a:noFill/>
+                    </a:lnT>
+                    <a:lnB>
+                      <a:noFill/>
+                    </a:lnB>
+                    <a:noFill/>
+                  </a:tcPr>
+                </a:tc>
+                <a:extLst>
+                  <a:ext uri="{0D108BD9-81ED-4DB2-BD59-A6C34878D82A}">
+                    <a16:rowId xmlns:a16="http://schemas.microsoft.com/office/drawing/2014/main" val="3694894323"/>
+                  </a:ext>
+                </a:extLst>
+              </a:tr>
+              <a:tr h="244929">
+                <a:tc>
+                  <a:txBody>
+                    <a:bodyPr/>
+                    <a:lstStyle/>
+                    <a:p>
+                      <a:pPr>
+                        <a:buNone/>
+                      </a:pPr>
+                      <a:r>
+                        <a:rPr lang="en-US" sz="1100" dirty="0">
+                          <a:latin typeface="Courier New" panose="02070309020205020404" pitchFamily="49" charset="0"/>
+                        </a:rPr>
+                        <a:t>255.255.255.255</a:t>
+                      </a:r>
+                      <a:endParaRPr lang="en-US" sz="1100" dirty="0"/>
+                    </a:p>
+                  </a:txBody>
+                  <a:tcPr marL="78377" marR="78377" marT="39189" marB="39189" anchor="ctr">
+                    <a:lnL>
+                      <a:noFill/>
+                    </a:lnL>
+                    <a:lnR>
+                      <a:noFill/>
+                    </a:lnR>
+                    <a:lnT>
+                      <a:noFill/>
+                    </a:lnT>
+                    <a:lnB>
+                      <a:noFill/>
+                    </a:lnB>
+                    <a:solidFill>
+                      <a:schemeClr val="bg2">
+                        <a:lumMod val="60000"/>
+                        <a:lumOff val="40000"/>
+                      </a:schemeClr>
+                    </a:solidFill>
+                  </a:tcPr>
+                </a:tc>
+                <a:tc>
+                  <a:txBody>
+                    <a:bodyPr/>
+                    <a:lstStyle/>
+                    <a:p>
+                      <a:pPr>
+                        <a:buNone/>
+                      </a:pPr>
+                      <a:r>
+                        <a:rPr lang="en-US" sz="1100" dirty="0"/>
+                        <a:t>Limited broadcast</a:t>
+                      </a:r>
+                    </a:p>
+                  </a:txBody>
+                  <a:tcPr marL="78377" marR="78377" marT="39189" marB="39189" anchor="ctr">
+                    <a:lnL>
+                      <a:noFill/>
+                    </a:lnL>
+                    <a:lnR>
+                      <a:noFill/>
+                    </a:lnR>
+                    <a:lnT>
+                      <a:noFill/>
+                    </a:lnT>
+                    <a:lnB>
+                      <a:noFill/>
+                    </a:lnB>
+                    <a:solidFill>
+                      <a:schemeClr val="bg2">
+                        <a:lumMod val="60000"/>
+                        <a:lumOff val="40000"/>
+                      </a:schemeClr>
+                    </a:solidFill>
+                  </a:tcPr>
+                </a:tc>
+                <a:extLst>
+                  <a:ext uri="{0D108BD9-81ED-4DB2-BD59-A6C34878D82A}">
+                    <a16:rowId xmlns:a16="http://schemas.microsoft.com/office/drawing/2014/main" val="3708814282"/>
+                  </a:ext>
+                </a:extLst>
+              </a:tr>
+            </a:tbl>
+          </a:graphicData>
+        </a:graphic>
+      </p:graphicFrame>
+    </p:spTree>
+    <p:extLst>
+      <p:ext uri="{BB962C8B-B14F-4D97-AF65-F5344CB8AC3E}">
+        <p14:creationId xmlns:p14="http://schemas.microsoft.com/office/powerpoint/2010/main" val="3299692619"/>
+      </p:ext>
+    </p:extLst>
+  </p:cSld>
+  <p:clrMapOvr>
+    <a:masterClrMapping/>
+  </p:clrMapOvr>
+</p:sld>
+</file>
+
+<file path=ppt/slides/slide11.xml><?xml version="1.0" encoding="utf-8"?>
 <p:sld xmlns:a="http://schemas.openxmlformats.org/drawingml/2006/main" xmlns:r="http://schemas.openxmlformats.org/officeDocument/2006/relationships" xmlns:p="http://schemas.openxmlformats.org/presentationml/2006/main">
   <p:cSld>
     <p:spTree>
@@ -21705,7 +22892,7 @@
 </p:sld>
 </file>
 
-<file path=ppt/slides/slide11.xml><?xml version="1.0" encoding="utf-8"?>
+<file path=ppt/slides/slide12.xml><?xml version="1.0" encoding="utf-8"?>
 <p:sld xmlns:a="http://schemas.openxmlformats.org/drawingml/2006/main" xmlns:r="http://schemas.openxmlformats.org/officeDocument/2006/relationships" xmlns:p="http://schemas.openxmlformats.org/presentationml/2006/main">
   <p:cSld>
     <p:spTree>
@@ -22196,7 +23383,7 @@
 </p:sld>
 </file>
 
-<file path=ppt/slides/slide12.xml><?xml version="1.0" encoding="utf-8"?>
+<file path=ppt/slides/slide13.xml><?xml version="1.0" encoding="utf-8"?>
 <p:sld xmlns:a="http://schemas.openxmlformats.org/drawingml/2006/main" xmlns:r="http://schemas.openxmlformats.org/officeDocument/2006/relationships" xmlns:p="http://schemas.openxmlformats.org/presentationml/2006/main">
   <p:cSld>
     <p:spTree>
@@ -22285,7 +23472,7 @@
 </p:sld>
 </file>
 
-<file path=ppt/slides/slide13.xml><?xml version="1.0" encoding="utf-8"?>
+<file path=ppt/slides/slide14.xml><?xml version="1.0" encoding="utf-8"?>
 <p:sld xmlns:a="http://schemas.openxmlformats.org/drawingml/2006/main" xmlns:r="http://schemas.openxmlformats.org/officeDocument/2006/relationships" xmlns:p="http://schemas.openxmlformats.org/presentationml/2006/main">
   <p:cSld>
     <p:spTree>
@@ -22477,7 +23664,7 @@
 </p:sld>
 </file>
 
-<file path=ppt/slides/slide14.xml><?xml version="1.0" encoding="utf-8"?>
+<file path=ppt/slides/slide15.xml><?xml version="1.0" encoding="utf-8"?>
 <p:sld xmlns:a="http://schemas.openxmlformats.org/drawingml/2006/main" xmlns:r="http://schemas.openxmlformats.org/officeDocument/2006/relationships" xmlns:p="http://schemas.openxmlformats.org/presentationml/2006/main">
   <p:cSld>
     <p:spTree>
@@ -24810,7 +25997,7 @@
 </p:sld>
 </file>
 
-<file path=ppt/slides/slide15.xml><?xml version="1.0" encoding="utf-8"?>
+<file path=ppt/slides/slide16.xml><?xml version="1.0" encoding="utf-8"?>
 <p:sld xmlns:a="http://schemas.openxmlformats.org/drawingml/2006/main" xmlns:r="http://schemas.openxmlformats.org/officeDocument/2006/relationships" xmlns:p="http://schemas.openxmlformats.org/presentationml/2006/main">
   <p:cSld>
     <p:spTree>
@@ -25101,7 +26288,7 @@
 </p:sld>
 </file>
 
-<file path=ppt/slides/slide16.xml><?xml version="1.0" encoding="utf-8"?>
+<file path=ppt/slides/slide17.xml><?xml version="1.0" encoding="utf-8"?>
 <p:sld xmlns:a="http://schemas.openxmlformats.org/drawingml/2006/main" xmlns:r="http://schemas.openxmlformats.org/officeDocument/2006/relationships" xmlns:p="http://schemas.openxmlformats.org/presentationml/2006/main">
   <p:cSld>
     <p:spTree>
@@ -25254,7 +26441,7 @@
 </p:sld>
 </file>
 
-<file path=ppt/slides/slide17.xml><?xml version="1.0" encoding="utf-8"?>
+<file path=ppt/slides/slide18.xml><?xml version="1.0" encoding="utf-8"?>
 <p:sld xmlns:a="http://schemas.openxmlformats.org/drawingml/2006/main" xmlns:r="http://schemas.openxmlformats.org/officeDocument/2006/relationships" xmlns:p="http://schemas.openxmlformats.org/presentationml/2006/main">
   <p:cSld>
     <p:spTree>
@@ -27672,7 +28859,7 @@
 </p:sld>
 </file>
 
-<file path=ppt/slides/slide18.xml><?xml version="1.0" encoding="utf-8"?>
+<file path=ppt/slides/slide19.xml><?xml version="1.0" encoding="utf-8"?>
 <p:sld xmlns:a="http://schemas.openxmlformats.org/drawingml/2006/main" xmlns:r="http://schemas.openxmlformats.org/officeDocument/2006/relationships" xmlns:p="http://schemas.openxmlformats.org/presentationml/2006/main">
   <p:cSld>
     <p:spTree>
@@ -29307,10 +30494,10 @@
       </p:grpSpPr>
       <p:sp>
         <p:nvSpPr>
-          <p:cNvPr id="20" name="Title 19">
+          <p:cNvPr id="2" name="Title 1">
             <a:extLst>
               <a:ext uri="{FF2B5EF4-FFF2-40B4-BE49-F238E27FC236}">
-                <a16:creationId xmlns:a16="http://schemas.microsoft.com/office/drawing/2014/main" id="{F067C8BD-9B8B-CCBD-E7C5-AD62B9BD699A}"/>
+                <a16:creationId xmlns:a16="http://schemas.microsoft.com/office/drawing/2014/main" id="{66CE557A-D8EE-586F-8079-0A93902038D8}"/>
               </a:ext>
             </a:extLst>
           </p:cNvPr>
@@ -29328,17 +30515,17 @@
           <a:p>
             <a:r>
               <a:rPr lang="en-US" dirty="0"/>
-              <a:t>IPv4 Addressing</a:t>
+              <a:t>A Brief Aside:  Protocols</a:t>
             </a:r>
           </a:p>
         </p:txBody>
       </p:sp>
       <p:sp>
         <p:nvSpPr>
-          <p:cNvPr id="21" name="Content Placeholder 20">
+          <p:cNvPr id="3" name="Content Placeholder 2">
             <a:extLst>
               <a:ext uri="{FF2B5EF4-FFF2-40B4-BE49-F238E27FC236}">
-                <a16:creationId xmlns:a16="http://schemas.microsoft.com/office/drawing/2014/main" id="{C2857B85-4FE8-52A1-6060-DD392458A4B3}"/>
+                <a16:creationId xmlns:a16="http://schemas.microsoft.com/office/drawing/2014/main" id="{45FB5F6A-09B3-908F-B298-8492DF86A495}"/>
               </a:ext>
             </a:extLst>
           </p:cNvPr>
@@ -29354,14 +30541,131 @@
           <a:bodyPr/>
           <a:lstStyle/>
           <a:p>
-            <a:endParaRPr lang="en-US"/>
+            <a:r>
+              <a:rPr lang="en-US" dirty="0"/>
+              <a:t>Ever interact with a protocol officer?</a:t>
+            </a:r>
+          </a:p>
+          <a:p>
+            <a:r>
+              <a:rPr lang="en-US" dirty="0"/>
+              <a:t>Protocols inform developers how to communicate</a:t>
+            </a:r>
+          </a:p>
+          <a:p>
+            <a:r>
+              <a:rPr lang="en-US" dirty="0"/>
+              <a:t>TTPs for software</a:t>
+            </a:r>
+          </a:p>
+          <a:p>
+            <a:pPr lvl="1"/>
+            <a:r>
+              <a:rPr lang="en-US" dirty="0"/>
+              <a:t>MUST, MUST NOT, SHOULD, SHOULD NOT</a:t>
+            </a:r>
+          </a:p>
+          <a:p>
+            <a:pPr lvl="1"/>
+            <a:r>
+              <a:rPr lang="en-US" dirty="0"/>
+              <a:t>Data types, formatting, extensibility</a:t>
+            </a:r>
+          </a:p>
+          <a:p>
+            <a:pPr lvl="1"/>
+            <a:endParaRPr lang="en-US" dirty="0"/>
+          </a:p>
+        </p:txBody>
+      </p:sp>
+      <p:sp>
+        <p:nvSpPr>
+          <p:cNvPr id="4" name="Content Placeholder 3">
+            <a:extLst>
+              <a:ext uri="{FF2B5EF4-FFF2-40B4-BE49-F238E27FC236}">
+                <a16:creationId xmlns:a16="http://schemas.microsoft.com/office/drawing/2014/main" id="{D7FDD489-E1C3-6305-9CDA-A638DB540CB3}"/>
+              </a:ext>
+            </a:extLst>
+          </p:cNvPr>
+          <p:cNvSpPr>
+            <a:spLocks noGrp="1"/>
+          </p:cNvSpPr>
+          <p:nvPr>
+            <p:ph sz="half" idx="2"/>
+          </p:nvPr>
+        </p:nvSpPr>
+        <p:spPr/>
+        <p:txBody>
+          <a:bodyPr/>
+          <a:lstStyle/>
+          <a:p>
+            <a:r>
+              <a:rPr lang="en-US" dirty="0"/>
+              <a:t>Common protocols</a:t>
+            </a:r>
+          </a:p>
+          <a:p>
+            <a:pPr lvl="1"/>
+            <a:r>
+              <a:rPr lang="en-US" dirty="0"/>
+              <a:t>Ethernet</a:t>
+            </a:r>
+          </a:p>
+          <a:p>
+            <a:pPr lvl="1"/>
+            <a:r>
+              <a:rPr lang="en-US" dirty="0"/>
+              <a:t>IP</a:t>
+            </a:r>
+          </a:p>
+          <a:p>
+            <a:pPr lvl="1"/>
+            <a:r>
+              <a:rPr lang="en-US" dirty="0"/>
+              <a:t>TCP</a:t>
+            </a:r>
+          </a:p>
+          <a:p>
+            <a:pPr lvl="1"/>
+            <a:r>
+              <a:rPr lang="en-US" dirty="0"/>
+              <a:t>UDP</a:t>
+            </a:r>
+          </a:p>
+          <a:p>
+            <a:pPr lvl="1"/>
+            <a:r>
+              <a:rPr lang="en-US" dirty="0"/>
+              <a:t>TLS/SSL</a:t>
+            </a:r>
+          </a:p>
+          <a:p>
+            <a:pPr lvl="1"/>
+            <a:r>
+              <a:rPr lang="en-US" dirty="0"/>
+              <a:t>HTTP</a:t>
+            </a:r>
+          </a:p>
+          <a:p>
+            <a:pPr lvl="1"/>
+            <a:r>
+              <a:rPr lang="en-US" dirty="0"/>
+              <a:t>SMTP</a:t>
+            </a:r>
+          </a:p>
+          <a:p>
+            <a:pPr lvl="1"/>
+            <a:r>
+              <a:rPr lang="en-US" dirty="0"/>
+              <a:t>FTP</a:t>
+            </a:r>
           </a:p>
         </p:txBody>
       </p:sp>
     </p:spTree>
     <p:extLst>
       <p:ext uri="{BB962C8B-B14F-4D97-AF65-F5344CB8AC3E}">
-        <p14:creationId xmlns:p14="http://schemas.microsoft.com/office/powerpoint/2010/main" val="140431678"/>
+        <p14:creationId xmlns:p14="http://schemas.microsoft.com/office/powerpoint/2010/main" val="2001471618"/>
       </p:ext>
     </p:extLst>
   </p:cSld>
@@ -29390,6 +30694,89 @@
       </p:grpSpPr>
       <p:sp>
         <p:nvSpPr>
+          <p:cNvPr id="20" name="Title 19">
+            <a:extLst>
+              <a:ext uri="{FF2B5EF4-FFF2-40B4-BE49-F238E27FC236}">
+                <a16:creationId xmlns:a16="http://schemas.microsoft.com/office/drawing/2014/main" id="{F067C8BD-9B8B-CCBD-E7C5-AD62B9BD699A}"/>
+              </a:ext>
+            </a:extLst>
+          </p:cNvPr>
+          <p:cNvSpPr>
+            <a:spLocks noGrp="1"/>
+          </p:cNvSpPr>
+          <p:nvPr>
+            <p:ph type="title"/>
+          </p:nvPr>
+        </p:nvSpPr>
+        <p:spPr/>
+        <p:txBody>
+          <a:bodyPr/>
+          <a:lstStyle/>
+          <a:p>
+            <a:r>
+              <a:rPr lang="en-US" dirty="0"/>
+              <a:t>IPv4 Addressing</a:t>
+            </a:r>
+          </a:p>
+        </p:txBody>
+      </p:sp>
+      <p:sp>
+        <p:nvSpPr>
+          <p:cNvPr id="21" name="Content Placeholder 20">
+            <a:extLst>
+              <a:ext uri="{FF2B5EF4-FFF2-40B4-BE49-F238E27FC236}">
+                <a16:creationId xmlns:a16="http://schemas.microsoft.com/office/drawing/2014/main" id="{C2857B85-4FE8-52A1-6060-DD392458A4B3}"/>
+              </a:ext>
+            </a:extLst>
+          </p:cNvPr>
+          <p:cNvSpPr>
+            <a:spLocks noGrp="1"/>
+          </p:cNvSpPr>
+          <p:nvPr>
+            <p:ph sz="half" idx="1"/>
+          </p:nvPr>
+        </p:nvSpPr>
+        <p:spPr/>
+        <p:txBody>
+          <a:bodyPr/>
+          <a:lstStyle/>
+          <a:p>
+            <a:endParaRPr lang="en-US"/>
+          </a:p>
+        </p:txBody>
+      </p:sp>
+    </p:spTree>
+    <p:extLst>
+      <p:ext uri="{BB962C8B-B14F-4D97-AF65-F5344CB8AC3E}">
+        <p14:creationId xmlns:p14="http://schemas.microsoft.com/office/powerpoint/2010/main" val="140431678"/>
+      </p:ext>
+    </p:extLst>
+  </p:cSld>
+  <p:clrMapOvr>
+    <a:masterClrMapping/>
+  </p:clrMapOvr>
+</p:sld>
+</file>
+
+<file path=ppt/slides/slide7.xml><?xml version="1.0" encoding="utf-8"?>
+<p:sld xmlns:a="http://schemas.openxmlformats.org/drawingml/2006/main" xmlns:r="http://schemas.openxmlformats.org/officeDocument/2006/relationships" xmlns:p="http://schemas.openxmlformats.org/presentationml/2006/main">
+  <p:cSld>
+    <p:spTree>
+      <p:nvGrpSpPr>
+        <p:cNvPr id="1" name=""/>
+        <p:cNvGrpSpPr/>
+        <p:nvPr/>
+      </p:nvGrpSpPr>
+      <p:grpSpPr>
+        <a:xfrm>
+          <a:off x="0" y="0"/>
+          <a:ext cx="0" cy="0"/>
+          <a:chOff x="0" y="0"/>
+          <a:chExt cx="0" cy="0"/>
+        </a:xfrm>
+      </p:grpSpPr>
+      <p:sp>
+        <p:nvSpPr>
           <p:cNvPr id="2" name="Title 1">
             <a:extLst>
               <a:ext uri="{FF2B5EF4-FFF2-40B4-BE49-F238E27FC236}">
@@ -29743,7 +31130,7 @@
 </p:sld>
 </file>
 
-<file path=ppt/slides/slide7.xml><?xml version="1.0" encoding="utf-8"?>
+<file path=ppt/slides/slide8.xml><?xml version="1.0" encoding="utf-8"?>
 <p:sld xmlns:a="http://schemas.openxmlformats.org/drawingml/2006/main" xmlns:r="http://schemas.openxmlformats.org/officeDocument/2006/relationships" xmlns:p="http://schemas.openxmlformats.org/presentationml/2006/main">
   <p:cSld>
     <p:spTree>
@@ -30122,7 +31509,7 @@
 </p:sld>
 </file>
 
-<file path=ppt/slides/slide8.xml><?xml version="1.0" encoding="utf-8"?>
+<file path=ppt/slides/slide9.xml><?xml version="1.0" encoding="utf-8"?>
 <p:sld xmlns:a="http://schemas.openxmlformats.org/drawingml/2006/main" xmlns:r="http://schemas.openxmlformats.org/officeDocument/2006/relationships" xmlns:p="http://schemas.openxmlformats.org/presentationml/2006/main">
   <p:cSld>
     <p:spTree>
@@ -31200,1192 +32587,6 @@
 </p:sld>
 </file>
 
-<file path=ppt/slides/slide9.xml><?xml version="1.0" encoding="utf-8"?>
-<p:sld xmlns:a="http://schemas.openxmlformats.org/drawingml/2006/main" xmlns:r="http://schemas.openxmlformats.org/officeDocument/2006/relationships" xmlns:p="http://schemas.openxmlformats.org/presentationml/2006/main">
-  <p:cSld>
-    <p:spTree>
-      <p:nvGrpSpPr>
-        <p:cNvPr id="1" name=""/>
-        <p:cNvGrpSpPr/>
-        <p:nvPr/>
-      </p:nvGrpSpPr>
-      <p:grpSpPr>
-        <a:xfrm>
-          <a:off x="0" y="0"/>
-          <a:ext cx="0" cy="0"/>
-          <a:chOff x="0" y="0"/>
-          <a:chExt cx="0" cy="0"/>
-        </a:xfrm>
-      </p:grpSpPr>
-      <p:sp>
-        <p:nvSpPr>
-          <p:cNvPr id="2" name="Title 1">
-            <a:extLst>
-              <a:ext uri="{FF2B5EF4-FFF2-40B4-BE49-F238E27FC236}">
-                <a16:creationId xmlns:a16="http://schemas.microsoft.com/office/drawing/2014/main" id="{DEDB0583-9E7A-9535-B8F3-618E763A9746}"/>
-              </a:ext>
-            </a:extLst>
-          </p:cNvPr>
-          <p:cNvSpPr>
-            <a:spLocks noGrp="1"/>
-          </p:cNvSpPr>
-          <p:nvPr>
-            <p:ph type="title"/>
-          </p:nvPr>
-        </p:nvSpPr>
-        <p:spPr/>
-        <p:txBody>
-          <a:bodyPr/>
-          <a:lstStyle/>
-          <a:p>
-            <a:r>
-              <a:rPr lang="en-US" dirty="0"/>
-              <a:t>IPv4 Addressing – Reserved Addresses</a:t>
-            </a:r>
-          </a:p>
-        </p:txBody>
-      </p:sp>
-      <p:graphicFrame>
-        <p:nvGraphicFramePr>
-          <p:cNvPr id="8" name="Content Placeholder 7">
-            <a:extLst>
-              <a:ext uri="{FF2B5EF4-FFF2-40B4-BE49-F238E27FC236}">
-                <a16:creationId xmlns:a16="http://schemas.microsoft.com/office/drawing/2014/main" id="{5E94FF6C-B6DB-83B0-18FA-B1AE514D6C66}"/>
-              </a:ext>
-            </a:extLst>
-          </p:cNvPr>
-          <p:cNvGraphicFramePr>
-            <a:graphicFrameLocks noGrp="1"/>
-          </p:cNvGraphicFramePr>
-          <p:nvPr>
-            <p:ph sz="half" idx="2"/>
-            <p:extLst>
-              <p:ext uri="{D42A27DB-BD31-4B8C-83A1-F6EECF244321}">
-                <p14:modId xmlns:p14="http://schemas.microsoft.com/office/powerpoint/2010/main" val="2172834210"/>
-              </p:ext>
-            </p:extLst>
-          </p:nvPr>
-        </p:nvGraphicFramePr>
-        <p:xfrm>
-          <a:off x="2017876" y="1222997"/>
-          <a:ext cx="4475578" cy="3611892"/>
-        </p:xfrm>
-        <a:graphic>
-          <a:graphicData uri="http://schemas.openxmlformats.org/drawingml/2006/table">
-            <a:tbl>
-              <a:tblPr/>
-              <a:tblGrid>
-                <a:gridCol w="2237789">
-                  <a:extLst>
-                    <a:ext uri="{9D8B030D-6E8A-4147-A177-3AD203B41FA5}">
-                      <a16:colId xmlns:a16="http://schemas.microsoft.com/office/drawing/2014/main" val="2893615785"/>
-                    </a:ext>
-                  </a:extLst>
-                </a:gridCol>
-                <a:gridCol w="2237789">
-                  <a:extLst>
-                    <a:ext uri="{9D8B030D-6E8A-4147-A177-3AD203B41FA5}">
-                      <a16:colId xmlns:a16="http://schemas.microsoft.com/office/drawing/2014/main" val="3977585347"/>
-                    </a:ext>
-                  </a:extLst>
-                </a:gridCol>
-              </a:tblGrid>
-              <a:tr h="244929">
-                <a:tc>
-                  <a:txBody>
-                    <a:bodyPr/>
-                    <a:lstStyle/>
-                    <a:p>
-                      <a:pPr>
-                        <a:buNone/>
-                      </a:pPr>
-                      <a:r>
-                        <a:rPr lang="en-US" sz="1100" b="1" dirty="0"/>
-                        <a:t>Network Range</a:t>
-                      </a:r>
-                    </a:p>
-                  </a:txBody>
-                  <a:tcPr marL="78377" marR="78377" marT="39189" marB="39189" anchor="ctr">
-                    <a:lnL>
-                      <a:noFill/>
-                    </a:lnL>
-                    <a:lnR>
-                      <a:noFill/>
-                    </a:lnR>
-                    <a:lnT>
-                      <a:noFill/>
-                    </a:lnT>
-                    <a:lnB>
-                      <a:noFill/>
-                    </a:lnB>
-                    <a:noFill/>
-                  </a:tcPr>
-                </a:tc>
-                <a:tc>
-                  <a:txBody>
-                    <a:bodyPr/>
-                    <a:lstStyle/>
-                    <a:p>
-                      <a:pPr>
-                        <a:buNone/>
-                      </a:pPr>
-                      <a:r>
-                        <a:rPr lang="en-US" sz="1100" b="1" dirty="0"/>
-                        <a:t>Purpose</a:t>
-                      </a:r>
-                    </a:p>
-                  </a:txBody>
-                  <a:tcPr marL="78377" marR="78377" marT="39189" marB="39189" anchor="ctr">
-                    <a:lnL>
-                      <a:noFill/>
-                    </a:lnL>
-                    <a:lnR>
-                      <a:noFill/>
-                    </a:lnR>
-                    <a:lnT>
-                      <a:noFill/>
-                    </a:lnT>
-                    <a:lnB>
-                      <a:noFill/>
-                    </a:lnB>
-                    <a:noFill/>
-                  </a:tcPr>
-                </a:tc>
-                <a:extLst>
-                  <a:ext uri="{0D108BD9-81ED-4DB2-BD59-A6C34878D82A}">
-                    <a16:rowId xmlns:a16="http://schemas.microsoft.com/office/drawing/2014/main" val="3385045340"/>
-                  </a:ext>
-                </a:extLst>
-              </a:tr>
-              <a:tr h="244929">
-                <a:tc>
-                  <a:txBody>
-                    <a:bodyPr/>
-                    <a:lstStyle/>
-                    <a:p>
-                      <a:pPr>
-                        <a:buNone/>
-                      </a:pPr>
-                      <a:r>
-                        <a:rPr lang="en-US" sz="1100" dirty="0">
-                          <a:latin typeface="Courier New" panose="02070309020205020404" pitchFamily="49" charset="0"/>
-                        </a:rPr>
-                        <a:t>0.0.0.0/8</a:t>
-                      </a:r>
-                      <a:endParaRPr lang="en-US" sz="1100" dirty="0"/>
-                    </a:p>
-                  </a:txBody>
-                  <a:tcPr marL="78377" marR="78377" marT="39189" marB="39189" anchor="ctr">
-                    <a:lnL>
-                      <a:noFill/>
-                    </a:lnL>
-                    <a:lnR>
-                      <a:noFill/>
-                    </a:lnR>
-                    <a:lnT>
-                      <a:noFill/>
-                    </a:lnT>
-                    <a:lnB>
-                      <a:noFill/>
-                    </a:lnB>
-                    <a:noFill/>
-                  </a:tcPr>
-                </a:tc>
-                <a:tc>
-                  <a:txBody>
-                    <a:bodyPr/>
-                    <a:lstStyle/>
-                    <a:p>
-                      <a:pPr>
-                        <a:buNone/>
-                      </a:pPr>
-                      <a:r>
-                        <a:rPr lang="en-US" sz="1100" dirty="0"/>
-                        <a:t>Network identification, default routes</a:t>
-                      </a:r>
-                    </a:p>
-                  </a:txBody>
-                  <a:tcPr marL="78377" marR="78377" marT="39189" marB="39189" anchor="ctr">
-                    <a:lnL>
-                      <a:noFill/>
-                    </a:lnL>
-                    <a:lnR>
-                      <a:noFill/>
-                    </a:lnR>
-                    <a:lnT>
-                      <a:noFill/>
-                    </a:lnT>
-                    <a:lnB>
-                      <a:noFill/>
-                    </a:lnB>
-                    <a:noFill/>
-                  </a:tcPr>
-                </a:tc>
-                <a:extLst>
-                  <a:ext uri="{0D108BD9-81ED-4DB2-BD59-A6C34878D82A}">
-                    <a16:rowId xmlns:a16="http://schemas.microsoft.com/office/drawing/2014/main" val="3800661372"/>
-                  </a:ext>
-                </a:extLst>
-              </a:tr>
-              <a:tr h="244929">
-                <a:tc>
-                  <a:txBody>
-                    <a:bodyPr/>
-                    <a:lstStyle/>
-                    <a:p>
-                      <a:pPr>
-                        <a:buNone/>
-                      </a:pPr>
-                      <a:r>
-                        <a:rPr lang="en-US" sz="1100">
-                          <a:latin typeface="Courier New" panose="02070309020205020404" pitchFamily="49" charset="0"/>
-                        </a:rPr>
-                        <a:t>10.0.0.0/8</a:t>
-                      </a:r>
-                      <a:endParaRPr lang="en-US" sz="1100"/>
-                    </a:p>
-                  </a:txBody>
-                  <a:tcPr marL="78377" marR="78377" marT="39189" marB="39189" anchor="ctr">
-                    <a:lnL>
-                      <a:noFill/>
-                    </a:lnL>
-                    <a:lnR>
-                      <a:noFill/>
-                    </a:lnR>
-                    <a:lnT>
-                      <a:noFill/>
-                    </a:lnT>
-                    <a:lnB>
-                      <a:noFill/>
-                    </a:lnB>
-                    <a:solidFill>
-                      <a:schemeClr val="bg2">
-                        <a:lumMod val="60000"/>
-                        <a:lumOff val="40000"/>
-                      </a:schemeClr>
-                    </a:solidFill>
-                  </a:tcPr>
-                </a:tc>
-                <a:tc>
-                  <a:txBody>
-                    <a:bodyPr/>
-                    <a:lstStyle/>
-                    <a:p>
-                      <a:pPr>
-                        <a:buNone/>
-                      </a:pPr>
-                      <a:r>
-                        <a:rPr lang="en-US" sz="1100" dirty="0">
-                          <a:highlight>
-                            <a:srgbClr val="FFFF00"/>
-                          </a:highlight>
-                        </a:rPr>
-                        <a:t>Private</a:t>
-                      </a:r>
-                      <a:r>
-                        <a:rPr lang="en-US" sz="1100" dirty="0"/>
-                        <a:t> networks (RFC 1918)</a:t>
-                      </a:r>
-                    </a:p>
-                  </a:txBody>
-                  <a:tcPr marL="78377" marR="78377" marT="39189" marB="39189" anchor="ctr">
-                    <a:lnL>
-                      <a:noFill/>
-                    </a:lnL>
-                    <a:lnR>
-                      <a:noFill/>
-                    </a:lnR>
-                    <a:lnT>
-                      <a:noFill/>
-                    </a:lnT>
-                    <a:lnB>
-                      <a:noFill/>
-                    </a:lnB>
-                    <a:solidFill>
-                      <a:schemeClr val="bg2">
-                        <a:lumMod val="60000"/>
-                        <a:lumOff val="40000"/>
-                      </a:schemeClr>
-                    </a:solidFill>
-                  </a:tcPr>
-                </a:tc>
-                <a:extLst>
-                  <a:ext uri="{0D108BD9-81ED-4DB2-BD59-A6C34878D82A}">
-                    <a16:rowId xmlns:a16="http://schemas.microsoft.com/office/drawing/2014/main" val="4259145204"/>
-                  </a:ext>
-                </a:extLst>
-              </a:tr>
-              <a:tr h="244929">
-                <a:tc>
-                  <a:txBody>
-                    <a:bodyPr/>
-                    <a:lstStyle/>
-                    <a:p>
-                      <a:pPr>
-                        <a:buNone/>
-                      </a:pPr>
-                      <a:r>
-                        <a:rPr lang="en-US" sz="1100">
-                          <a:latin typeface="Courier New" panose="02070309020205020404" pitchFamily="49" charset="0"/>
-                        </a:rPr>
-                        <a:t>100.64.0.0/10</a:t>
-                      </a:r>
-                      <a:endParaRPr lang="en-US" sz="1100"/>
-                    </a:p>
-                  </a:txBody>
-                  <a:tcPr marL="78377" marR="78377" marT="39189" marB="39189" anchor="ctr">
-                    <a:lnL>
-                      <a:noFill/>
-                    </a:lnL>
-                    <a:lnR>
-                      <a:noFill/>
-                    </a:lnR>
-                    <a:lnT>
-                      <a:noFill/>
-                    </a:lnT>
-                    <a:lnB>
-                      <a:noFill/>
-                    </a:lnB>
-                    <a:noFill/>
-                  </a:tcPr>
-                </a:tc>
-                <a:tc>
-                  <a:txBody>
-                    <a:bodyPr/>
-                    <a:lstStyle/>
-                    <a:p>
-                      <a:pPr>
-                        <a:buNone/>
-                      </a:pPr>
-                      <a:r>
-                        <a:rPr lang="en-US" sz="1100" dirty="0"/>
-                        <a:t>Carrier-grade NAT (CGNAT)</a:t>
-                      </a:r>
-                    </a:p>
-                  </a:txBody>
-                  <a:tcPr marL="78377" marR="78377" marT="39189" marB="39189" anchor="ctr">
-                    <a:lnL>
-                      <a:noFill/>
-                    </a:lnL>
-                    <a:lnR>
-                      <a:noFill/>
-                    </a:lnR>
-                    <a:lnT>
-                      <a:noFill/>
-                    </a:lnT>
-                    <a:lnB>
-                      <a:noFill/>
-                    </a:lnB>
-                    <a:noFill/>
-                  </a:tcPr>
-                </a:tc>
-                <a:extLst>
-                  <a:ext uri="{0D108BD9-81ED-4DB2-BD59-A6C34878D82A}">
-                    <a16:rowId xmlns:a16="http://schemas.microsoft.com/office/drawing/2014/main" val="3521821730"/>
-                  </a:ext>
-                </a:extLst>
-              </a:tr>
-              <a:tr h="244929">
-                <a:tc>
-                  <a:txBody>
-                    <a:bodyPr/>
-                    <a:lstStyle/>
-                    <a:p>
-                      <a:pPr>
-                        <a:buNone/>
-                      </a:pPr>
-                      <a:r>
-                        <a:rPr lang="en-US" sz="1100" dirty="0">
-                          <a:latin typeface="Courier New" panose="02070309020205020404" pitchFamily="49" charset="0"/>
-                        </a:rPr>
-                        <a:t>127.0.0.0/8</a:t>
-                      </a:r>
-                      <a:endParaRPr lang="en-US" sz="1100" dirty="0"/>
-                    </a:p>
-                  </a:txBody>
-                  <a:tcPr marL="78377" marR="78377" marT="39189" marB="39189" anchor="ctr">
-                    <a:lnL>
-                      <a:noFill/>
-                    </a:lnL>
-                    <a:lnR>
-                      <a:noFill/>
-                    </a:lnR>
-                    <a:lnT>
-                      <a:noFill/>
-                    </a:lnT>
-                    <a:lnB>
-                      <a:noFill/>
-                    </a:lnB>
-                    <a:solidFill>
-                      <a:schemeClr val="bg2">
-                        <a:lumMod val="60000"/>
-                        <a:lumOff val="40000"/>
-                      </a:schemeClr>
-                    </a:solidFill>
-                  </a:tcPr>
-                </a:tc>
-                <a:tc>
-                  <a:txBody>
-                    <a:bodyPr/>
-                    <a:lstStyle/>
-                    <a:p>
-                      <a:pPr>
-                        <a:buNone/>
-                      </a:pPr>
-                      <a:r>
-                        <a:rPr lang="en-US" sz="1100" dirty="0">
-                          <a:highlight>
-                            <a:srgbClr val="FFFF00"/>
-                          </a:highlight>
-                        </a:rPr>
-                        <a:t>Loopback</a:t>
-                      </a:r>
-                      <a:r>
-                        <a:rPr lang="en-US" sz="1100" dirty="0"/>
-                        <a:t> (localhost)</a:t>
-                      </a:r>
-                    </a:p>
-                  </a:txBody>
-                  <a:tcPr marL="78377" marR="78377" marT="39189" marB="39189" anchor="ctr">
-                    <a:lnL>
-                      <a:noFill/>
-                    </a:lnL>
-                    <a:lnR>
-                      <a:noFill/>
-                    </a:lnR>
-                    <a:lnT>
-                      <a:noFill/>
-                    </a:lnT>
-                    <a:lnB>
-                      <a:noFill/>
-                    </a:lnB>
-                    <a:solidFill>
-                      <a:schemeClr val="bg2">
-                        <a:lumMod val="60000"/>
-                        <a:lumOff val="40000"/>
-                      </a:schemeClr>
-                    </a:solidFill>
-                  </a:tcPr>
-                </a:tc>
-                <a:extLst>
-                  <a:ext uri="{0D108BD9-81ED-4DB2-BD59-A6C34878D82A}">
-                    <a16:rowId xmlns:a16="http://schemas.microsoft.com/office/drawing/2014/main" val="3354651175"/>
-                  </a:ext>
-                </a:extLst>
-              </a:tr>
-              <a:tr h="244929">
-                <a:tc>
-                  <a:txBody>
-                    <a:bodyPr/>
-                    <a:lstStyle/>
-                    <a:p>
-                      <a:pPr>
-                        <a:buNone/>
-                      </a:pPr>
-                      <a:r>
-                        <a:rPr lang="en-US" sz="1100">
-                          <a:latin typeface="Courier New" panose="02070309020205020404" pitchFamily="49" charset="0"/>
-                        </a:rPr>
-                        <a:t>169.254.0.0/16</a:t>
-                      </a:r>
-                      <a:endParaRPr lang="en-US" sz="1100"/>
-                    </a:p>
-                  </a:txBody>
-                  <a:tcPr marL="78377" marR="78377" marT="39189" marB="39189" anchor="ctr">
-                    <a:lnL>
-                      <a:noFill/>
-                    </a:lnL>
-                    <a:lnR>
-                      <a:noFill/>
-                    </a:lnR>
-                    <a:lnT>
-                      <a:noFill/>
-                    </a:lnT>
-                    <a:lnB>
-                      <a:noFill/>
-                    </a:lnB>
-                    <a:solidFill>
-                      <a:schemeClr val="bg2">
-                        <a:lumMod val="60000"/>
-                        <a:lumOff val="40000"/>
-                      </a:schemeClr>
-                    </a:solidFill>
-                  </a:tcPr>
-                </a:tc>
-                <a:tc>
-                  <a:txBody>
-                    <a:bodyPr/>
-                    <a:lstStyle/>
-                    <a:p>
-                      <a:pPr>
-                        <a:buNone/>
-                      </a:pPr>
-                      <a:r>
-                        <a:rPr lang="en-US" sz="1100" dirty="0"/>
-                        <a:t>Link-local (APIPA)</a:t>
-                      </a:r>
-                    </a:p>
-                  </a:txBody>
-                  <a:tcPr marL="78377" marR="78377" marT="39189" marB="39189" anchor="ctr">
-                    <a:lnL>
-                      <a:noFill/>
-                    </a:lnL>
-                    <a:lnR>
-                      <a:noFill/>
-                    </a:lnR>
-                    <a:lnT>
-                      <a:noFill/>
-                    </a:lnT>
-                    <a:lnB>
-                      <a:noFill/>
-                    </a:lnB>
-                    <a:solidFill>
-                      <a:schemeClr val="bg2">
-                        <a:lumMod val="60000"/>
-                        <a:lumOff val="40000"/>
-                      </a:schemeClr>
-                    </a:solidFill>
-                  </a:tcPr>
-                </a:tc>
-                <a:extLst>
-                  <a:ext uri="{0D108BD9-81ED-4DB2-BD59-A6C34878D82A}">
-                    <a16:rowId xmlns:a16="http://schemas.microsoft.com/office/drawing/2014/main" val="1054555260"/>
-                  </a:ext>
-                </a:extLst>
-              </a:tr>
-              <a:tr h="244929">
-                <a:tc>
-                  <a:txBody>
-                    <a:bodyPr/>
-                    <a:lstStyle/>
-                    <a:p>
-                      <a:pPr>
-                        <a:buNone/>
-                      </a:pPr>
-                      <a:r>
-                        <a:rPr lang="en-US" sz="1100" dirty="0">
-                          <a:latin typeface="Courier New" panose="02070309020205020404" pitchFamily="49" charset="0"/>
-                        </a:rPr>
-                        <a:t>172.16.0.0/12</a:t>
-                      </a:r>
-                      <a:endParaRPr lang="en-US" sz="1100" dirty="0"/>
-                    </a:p>
-                  </a:txBody>
-                  <a:tcPr marL="78377" marR="78377" marT="39189" marB="39189" anchor="ctr">
-                    <a:lnL>
-                      <a:noFill/>
-                    </a:lnL>
-                    <a:lnR>
-                      <a:noFill/>
-                    </a:lnR>
-                    <a:lnT>
-                      <a:noFill/>
-                    </a:lnT>
-                    <a:lnB>
-                      <a:noFill/>
-                    </a:lnB>
-                    <a:solidFill>
-                      <a:schemeClr val="bg2">
-                        <a:lumMod val="60000"/>
-                        <a:lumOff val="40000"/>
-                      </a:schemeClr>
-                    </a:solidFill>
-                  </a:tcPr>
-                </a:tc>
-                <a:tc>
-                  <a:txBody>
-                    <a:bodyPr/>
-                    <a:lstStyle/>
-                    <a:p>
-                      <a:pPr>
-                        <a:buNone/>
-                      </a:pPr>
-                      <a:r>
-                        <a:rPr lang="en-US" sz="1100" dirty="0">
-                          <a:highlight>
-                            <a:srgbClr val="FFFF00"/>
-                          </a:highlight>
-                        </a:rPr>
-                        <a:t>Private</a:t>
-                      </a:r>
-                      <a:r>
-                        <a:rPr lang="en-US" sz="1100" dirty="0"/>
-                        <a:t> networks (RFC 1918)</a:t>
-                      </a:r>
-                    </a:p>
-                  </a:txBody>
-                  <a:tcPr marL="78377" marR="78377" marT="39189" marB="39189" anchor="ctr">
-                    <a:lnL>
-                      <a:noFill/>
-                    </a:lnL>
-                    <a:lnR>
-                      <a:noFill/>
-                    </a:lnR>
-                    <a:lnT>
-                      <a:noFill/>
-                    </a:lnT>
-                    <a:lnB>
-                      <a:noFill/>
-                    </a:lnB>
-                    <a:solidFill>
-                      <a:schemeClr val="bg2">
-                        <a:lumMod val="60000"/>
-                        <a:lumOff val="40000"/>
-                      </a:schemeClr>
-                    </a:solidFill>
-                  </a:tcPr>
-                </a:tc>
-                <a:extLst>
-                  <a:ext uri="{0D108BD9-81ED-4DB2-BD59-A6C34878D82A}">
-                    <a16:rowId xmlns:a16="http://schemas.microsoft.com/office/drawing/2014/main" val="1296967149"/>
-                  </a:ext>
-                </a:extLst>
-              </a:tr>
-              <a:tr h="244929">
-                <a:tc>
-                  <a:txBody>
-                    <a:bodyPr/>
-                    <a:lstStyle/>
-                    <a:p>
-                      <a:pPr>
-                        <a:buNone/>
-                      </a:pPr>
-                      <a:r>
-                        <a:rPr lang="en-US" sz="1100">
-                          <a:latin typeface="Courier New" panose="02070309020205020404" pitchFamily="49" charset="0"/>
-                        </a:rPr>
-                        <a:t>192.0.0.0/24</a:t>
-                      </a:r>
-                      <a:endParaRPr lang="en-US" sz="1100"/>
-                    </a:p>
-                  </a:txBody>
-                  <a:tcPr marL="78377" marR="78377" marT="39189" marB="39189" anchor="ctr">
-                    <a:lnL>
-                      <a:noFill/>
-                    </a:lnL>
-                    <a:lnR>
-                      <a:noFill/>
-                    </a:lnR>
-                    <a:lnT>
-                      <a:noFill/>
-                    </a:lnT>
-                    <a:lnB>
-                      <a:noFill/>
-                    </a:lnB>
-                    <a:noFill/>
-                  </a:tcPr>
-                </a:tc>
-                <a:tc>
-                  <a:txBody>
-                    <a:bodyPr/>
-                    <a:lstStyle/>
-                    <a:p>
-                      <a:pPr>
-                        <a:buNone/>
-                      </a:pPr>
-                      <a:r>
-                        <a:rPr lang="en-US" sz="1100"/>
-                        <a:t>IETF Protocol Assignments</a:t>
-                      </a:r>
-                    </a:p>
-                  </a:txBody>
-                  <a:tcPr marL="78377" marR="78377" marT="39189" marB="39189" anchor="ctr">
-                    <a:lnL>
-                      <a:noFill/>
-                    </a:lnL>
-                    <a:lnR>
-                      <a:noFill/>
-                    </a:lnR>
-                    <a:lnT>
-                      <a:noFill/>
-                    </a:lnT>
-                    <a:lnB>
-                      <a:noFill/>
-                    </a:lnB>
-                    <a:noFill/>
-                  </a:tcPr>
-                </a:tc>
-                <a:extLst>
-                  <a:ext uri="{0D108BD9-81ED-4DB2-BD59-A6C34878D82A}">
-                    <a16:rowId xmlns:a16="http://schemas.microsoft.com/office/drawing/2014/main" val="18452452"/>
-                  </a:ext>
-                </a:extLst>
-              </a:tr>
-              <a:tr h="244929">
-                <a:tc>
-                  <a:txBody>
-                    <a:bodyPr/>
-                    <a:lstStyle/>
-                    <a:p>
-                      <a:pPr>
-                        <a:buNone/>
-                      </a:pPr>
-                      <a:r>
-                        <a:rPr lang="en-US" sz="1100" dirty="0">
-                          <a:latin typeface="Courier New" panose="02070309020205020404" pitchFamily="49" charset="0"/>
-                        </a:rPr>
-                        <a:t>192.168.0.0/16</a:t>
-                      </a:r>
-                      <a:endParaRPr lang="en-US" sz="1100" dirty="0"/>
-                    </a:p>
-                  </a:txBody>
-                  <a:tcPr marL="78377" marR="78377" marT="39189" marB="39189" anchor="ctr">
-                    <a:lnL>
-                      <a:noFill/>
-                    </a:lnL>
-                    <a:lnR>
-                      <a:noFill/>
-                    </a:lnR>
-                    <a:lnT>
-                      <a:noFill/>
-                    </a:lnT>
-                    <a:lnB>
-                      <a:noFill/>
-                    </a:lnB>
-                    <a:solidFill>
-                      <a:schemeClr val="bg2">
-                        <a:lumMod val="60000"/>
-                        <a:lumOff val="40000"/>
-                      </a:schemeClr>
-                    </a:solidFill>
-                  </a:tcPr>
-                </a:tc>
-                <a:tc>
-                  <a:txBody>
-                    <a:bodyPr/>
-                    <a:lstStyle/>
-                    <a:p>
-                      <a:pPr>
-                        <a:buNone/>
-                      </a:pPr>
-                      <a:r>
-                        <a:rPr lang="en-US" sz="1100" dirty="0">
-                          <a:highlight>
-                            <a:srgbClr val="FFFF00"/>
-                          </a:highlight>
-                        </a:rPr>
-                        <a:t>Private</a:t>
-                      </a:r>
-                      <a:r>
-                        <a:rPr lang="en-US" sz="1100" dirty="0"/>
-                        <a:t> networks (RFC 1918)</a:t>
-                      </a:r>
-                    </a:p>
-                  </a:txBody>
-                  <a:tcPr marL="78377" marR="78377" marT="39189" marB="39189" anchor="ctr">
-                    <a:lnL>
-                      <a:noFill/>
-                    </a:lnL>
-                    <a:lnR>
-                      <a:noFill/>
-                    </a:lnR>
-                    <a:lnT>
-                      <a:noFill/>
-                    </a:lnT>
-                    <a:lnB>
-                      <a:noFill/>
-                    </a:lnB>
-                    <a:solidFill>
-                      <a:schemeClr val="bg2">
-                        <a:lumMod val="60000"/>
-                        <a:lumOff val="40000"/>
-                      </a:schemeClr>
-                    </a:solidFill>
-                  </a:tcPr>
-                </a:tc>
-                <a:extLst>
-                  <a:ext uri="{0D108BD9-81ED-4DB2-BD59-A6C34878D82A}">
-                    <a16:rowId xmlns:a16="http://schemas.microsoft.com/office/drawing/2014/main" val="503910929"/>
-                  </a:ext>
-                </a:extLst>
-              </a:tr>
-              <a:tr h="244929">
-                <a:tc>
-                  <a:txBody>
-                    <a:bodyPr/>
-                    <a:lstStyle/>
-                    <a:p>
-                      <a:pPr>
-                        <a:buNone/>
-                      </a:pPr>
-                      <a:r>
-                        <a:rPr lang="en-US" sz="1100">
-                          <a:latin typeface="Courier New" panose="02070309020205020404" pitchFamily="49" charset="0"/>
-                        </a:rPr>
-                        <a:t>192.88.99.0/24</a:t>
-                      </a:r>
-                      <a:endParaRPr lang="en-US" sz="1100"/>
-                    </a:p>
-                  </a:txBody>
-                  <a:tcPr marL="78377" marR="78377" marT="39189" marB="39189" anchor="ctr">
-                    <a:lnL>
-                      <a:noFill/>
-                    </a:lnL>
-                    <a:lnR>
-                      <a:noFill/>
-                    </a:lnR>
-                    <a:lnT>
-                      <a:noFill/>
-                    </a:lnT>
-                    <a:lnB>
-                      <a:noFill/>
-                    </a:lnB>
-                    <a:noFill/>
-                  </a:tcPr>
-                </a:tc>
-                <a:tc>
-                  <a:txBody>
-                    <a:bodyPr/>
-                    <a:lstStyle/>
-                    <a:p>
-                      <a:pPr>
-                        <a:buNone/>
-                      </a:pPr>
-                      <a:r>
-                        <a:rPr lang="en-US" sz="1100"/>
-                        <a:t>IPv6-to-IPv4 relay (deprecated)</a:t>
-                      </a:r>
-                    </a:p>
-                  </a:txBody>
-                  <a:tcPr marL="78377" marR="78377" marT="39189" marB="39189" anchor="ctr">
-                    <a:lnL>
-                      <a:noFill/>
-                    </a:lnL>
-                    <a:lnR>
-                      <a:noFill/>
-                    </a:lnR>
-                    <a:lnT>
-                      <a:noFill/>
-                    </a:lnT>
-                    <a:lnB>
-                      <a:noFill/>
-                    </a:lnB>
-                    <a:noFill/>
-                  </a:tcPr>
-                </a:tc>
-                <a:extLst>
-                  <a:ext uri="{0D108BD9-81ED-4DB2-BD59-A6C34878D82A}">
-                    <a16:rowId xmlns:a16="http://schemas.microsoft.com/office/drawing/2014/main" val="1535487904"/>
-                  </a:ext>
-                </a:extLst>
-              </a:tr>
-              <a:tr h="244929">
-                <a:tc>
-                  <a:txBody>
-                    <a:bodyPr/>
-                    <a:lstStyle/>
-                    <a:p>
-                      <a:pPr>
-                        <a:buNone/>
-                      </a:pPr>
-                      <a:r>
-                        <a:rPr lang="en-US" sz="1100">
-                          <a:latin typeface="Courier New" panose="02070309020205020404" pitchFamily="49" charset="0"/>
-                        </a:rPr>
-                        <a:t>198.18.0.0/15</a:t>
-                      </a:r>
-                      <a:endParaRPr lang="en-US" sz="1100"/>
-                    </a:p>
-                  </a:txBody>
-                  <a:tcPr marL="78377" marR="78377" marT="39189" marB="39189" anchor="ctr">
-                    <a:lnL>
-                      <a:noFill/>
-                    </a:lnL>
-                    <a:lnR>
-                      <a:noFill/>
-                    </a:lnR>
-                    <a:lnT>
-                      <a:noFill/>
-                    </a:lnT>
-                    <a:lnB>
-                      <a:noFill/>
-                    </a:lnB>
-                    <a:noFill/>
-                  </a:tcPr>
-                </a:tc>
-                <a:tc>
-                  <a:txBody>
-                    <a:bodyPr/>
-                    <a:lstStyle/>
-                    <a:p>
-                      <a:pPr>
-                        <a:buNone/>
-                      </a:pPr>
-                      <a:r>
-                        <a:rPr lang="en-US" sz="1100"/>
-                        <a:t>Network benchmark testing</a:t>
-                      </a:r>
-                    </a:p>
-                  </a:txBody>
-                  <a:tcPr marL="78377" marR="78377" marT="39189" marB="39189" anchor="ctr">
-                    <a:lnL>
-                      <a:noFill/>
-                    </a:lnL>
-                    <a:lnR>
-                      <a:noFill/>
-                    </a:lnR>
-                    <a:lnT>
-                      <a:noFill/>
-                    </a:lnT>
-                    <a:lnB>
-                      <a:noFill/>
-                    </a:lnB>
-                    <a:noFill/>
-                  </a:tcPr>
-                </a:tc>
-                <a:extLst>
-                  <a:ext uri="{0D108BD9-81ED-4DB2-BD59-A6C34878D82A}">
-                    <a16:rowId xmlns:a16="http://schemas.microsoft.com/office/drawing/2014/main" val="3723439859"/>
-                  </a:ext>
-                </a:extLst>
-              </a:tr>
-              <a:tr h="244929">
-                <a:tc>
-                  <a:txBody>
-                    <a:bodyPr/>
-                    <a:lstStyle/>
-                    <a:p>
-                      <a:pPr>
-                        <a:buNone/>
-                      </a:pPr>
-                      <a:r>
-                        <a:rPr lang="en-US" sz="1100" dirty="0">
-                          <a:latin typeface="Courier New" panose="02070309020205020404" pitchFamily="49" charset="0"/>
-                        </a:rPr>
-                        <a:t>224.0.0.0/4</a:t>
-                      </a:r>
-                      <a:endParaRPr lang="en-US" sz="1100" dirty="0"/>
-                    </a:p>
-                  </a:txBody>
-                  <a:tcPr marL="78377" marR="78377" marT="39189" marB="39189" anchor="ctr">
-                    <a:lnL>
-                      <a:noFill/>
-                    </a:lnL>
-                    <a:lnR>
-                      <a:noFill/>
-                    </a:lnR>
-                    <a:lnT>
-                      <a:noFill/>
-                    </a:lnT>
-                    <a:lnB>
-                      <a:noFill/>
-                    </a:lnB>
-                    <a:solidFill>
-                      <a:schemeClr val="bg2">
-                        <a:lumMod val="60000"/>
-                        <a:lumOff val="40000"/>
-                      </a:schemeClr>
-                    </a:solidFill>
-                  </a:tcPr>
-                </a:tc>
-                <a:tc>
-                  <a:txBody>
-                    <a:bodyPr/>
-                    <a:lstStyle/>
-                    <a:p>
-                      <a:pPr>
-                        <a:buNone/>
-                      </a:pPr>
-                      <a:r>
-                        <a:rPr lang="en-US" sz="1100" dirty="0"/>
-                        <a:t>Multicast addresses</a:t>
-                      </a:r>
-                    </a:p>
-                  </a:txBody>
-                  <a:tcPr marL="78377" marR="78377" marT="39189" marB="39189" anchor="ctr">
-                    <a:lnL>
-                      <a:noFill/>
-                    </a:lnL>
-                    <a:lnR>
-                      <a:noFill/>
-                    </a:lnR>
-                    <a:lnT>
-                      <a:noFill/>
-                    </a:lnT>
-                    <a:lnB>
-                      <a:noFill/>
-                    </a:lnB>
-                    <a:solidFill>
-                      <a:schemeClr val="bg2">
-                        <a:lumMod val="60000"/>
-                        <a:lumOff val="40000"/>
-                      </a:schemeClr>
-                    </a:solidFill>
-                  </a:tcPr>
-                </a:tc>
-                <a:extLst>
-                  <a:ext uri="{0D108BD9-81ED-4DB2-BD59-A6C34878D82A}">
-                    <a16:rowId xmlns:a16="http://schemas.microsoft.com/office/drawing/2014/main" val="3207159718"/>
-                  </a:ext>
-                </a:extLst>
-              </a:tr>
-              <a:tr h="244929">
-                <a:tc>
-                  <a:txBody>
-                    <a:bodyPr/>
-                    <a:lstStyle/>
-                    <a:p>
-                      <a:pPr>
-                        <a:buNone/>
-                      </a:pPr>
-                      <a:r>
-                        <a:rPr lang="en-US" sz="1100">
-                          <a:latin typeface="Courier New" panose="02070309020205020404" pitchFamily="49" charset="0"/>
-                        </a:rPr>
-                        <a:t>240.0.0.0/4</a:t>
-                      </a:r>
-                      <a:endParaRPr lang="en-US" sz="1100"/>
-                    </a:p>
-                  </a:txBody>
-                  <a:tcPr marL="78377" marR="78377" marT="39189" marB="39189" anchor="ctr">
-                    <a:lnL>
-                      <a:noFill/>
-                    </a:lnL>
-                    <a:lnR>
-                      <a:noFill/>
-                    </a:lnR>
-                    <a:lnT>
-                      <a:noFill/>
-                    </a:lnT>
-                    <a:lnB>
-                      <a:noFill/>
-                    </a:lnB>
-                    <a:noFill/>
-                  </a:tcPr>
-                </a:tc>
-                <a:tc>
-                  <a:txBody>
-                    <a:bodyPr/>
-                    <a:lstStyle/>
-                    <a:p>
-                      <a:pPr>
-                        <a:buNone/>
-                      </a:pPr>
-                      <a:r>
-                        <a:rPr lang="en-US" sz="1100"/>
-                        <a:t>Reserved for future use</a:t>
-                      </a:r>
-                    </a:p>
-                  </a:txBody>
-                  <a:tcPr marL="78377" marR="78377" marT="39189" marB="39189" anchor="ctr">
-                    <a:lnL>
-                      <a:noFill/>
-                    </a:lnL>
-                    <a:lnR>
-                      <a:noFill/>
-                    </a:lnR>
-                    <a:lnT>
-                      <a:noFill/>
-                    </a:lnT>
-                    <a:lnB>
-                      <a:noFill/>
-                    </a:lnB>
-                    <a:noFill/>
-                  </a:tcPr>
-                </a:tc>
-                <a:extLst>
-                  <a:ext uri="{0D108BD9-81ED-4DB2-BD59-A6C34878D82A}">
-                    <a16:rowId xmlns:a16="http://schemas.microsoft.com/office/drawing/2014/main" val="3694894323"/>
-                  </a:ext>
-                </a:extLst>
-              </a:tr>
-              <a:tr h="244929">
-                <a:tc>
-                  <a:txBody>
-                    <a:bodyPr/>
-                    <a:lstStyle/>
-                    <a:p>
-                      <a:pPr>
-                        <a:buNone/>
-                      </a:pPr>
-                      <a:r>
-                        <a:rPr lang="en-US" sz="1100" dirty="0">
-                          <a:latin typeface="Courier New" panose="02070309020205020404" pitchFamily="49" charset="0"/>
-                        </a:rPr>
-                        <a:t>255.255.255.255</a:t>
-                      </a:r>
-                      <a:endParaRPr lang="en-US" sz="1100" dirty="0"/>
-                    </a:p>
-                  </a:txBody>
-                  <a:tcPr marL="78377" marR="78377" marT="39189" marB="39189" anchor="ctr">
-                    <a:lnL>
-                      <a:noFill/>
-                    </a:lnL>
-                    <a:lnR>
-                      <a:noFill/>
-                    </a:lnR>
-                    <a:lnT>
-                      <a:noFill/>
-                    </a:lnT>
-                    <a:lnB>
-                      <a:noFill/>
-                    </a:lnB>
-                    <a:solidFill>
-                      <a:schemeClr val="bg2">
-                        <a:lumMod val="60000"/>
-                        <a:lumOff val="40000"/>
-                      </a:schemeClr>
-                    </a:solidFill>
-                  </a:tcPr>
-                </a:tc>
-                <a:tc>
-                  <a:txBody>
-                    <a:bodyPr/>
-                    <a:lstStyle/>
-                    <a:p>
-                      <a:pPr>
-                        <a:buNone/>
-                      </a:pPr>
-                      <a:r>
-                        <a:rPr lang="en-US" sz="1100" dirty="0"/>
-                        <a:t>Limited broadcast</a:t>
-                      </a:r>
-                    </a:p>
-                  </a:txBody>
-                  <a:tcPr marL="78377" marR="78377" marT="39189" marB="39189" anchor="ctr">
-                    <a:lnL>
-                      <a:noFill/>
-                    </a:lnL>
-                    <a:lnR>
-                      <a:noFill/>
-                    </a:lnR>
-                    <a:lnT>
-                      <a:noFill/>
-                    </a:lnT>
-                    <a:lnB>
-                      <a:noFill/>
-                    </a:lnB>
-                    <a:solidFill>
-                      <a:schemeClr val="bg2">
-                        <a:lumMod val="60000"/>
-                        <a:lumOff val="40000"/>
-                      </a:schemeClr>
-                    </a:solidFill>
-                  </a:tcPr>
-                </a:tc>
-                <a:extLst>
-                  <a:ext uri="{0D108BD9-81ED-4DB2-BD59-A6C34878D82A}">
-                    <a16:rowId xmlns:a16="http://schemas.microsoft.com/office/drawing/2014/main" val="3708814282"/>
-                  </a:ext>
-                </a:extLst>
-              </a:tr>
-            </a:tbl>
-          </a:graphicData>
-        </a:graphic>
-      </p:graphicFrame>
-    </p:spTree>
-    <p:extLst>
-      <p:ext uri="{BB962C8B-B14F-4D97-AF65-F5344CB8AC3E}">
-        <p14:creationId xmlns:p14="http://schemas.microsoft.com/office/powerpoint/2010/main" val="3299692619"/>
-      </p:ext>
-    </p:extLst>
-  </p:cSld>
-  <p:clrMapOvr>
-    <a:masterClrMapping/>
-  </p:clrMapOvr>
-</p:sld>
-</file>
-
 <file path=ppt/theme/theme1.xml><?xml version="1.0" encoding="utf-8"?>
 <a:theme xmlns:a="http://schemas.openxmlformats.org/drawingml/2006/main" name="US Army 2023 AFC DEVCOM Logo">
   <a:themeElements>

</xml_diff>